<commit_message>
feat: add AC1 significance test to agreement comparison
- Two-tailed z-test on AC1 difference (agent vs R1 compared to R1 vs R2)
- SE derived from 95% CI, alpha = 0.05
- Added to frontend Agreement page: new "Significance" column
- Added to PPT: p-values + significance status for all 6 fields
- Result: no field shows statistically significant difference from human agreement
</commit_message>
<xml_diff>
--- a/amp_llm_v3/standalone modules/agent_annotate/docs/Agent_Annotate_Architecture.pptx
+++ b/amp_llm_v3/standalone modules/agent_annotate/docs/Agent_Annotate_Architecture.pptx
@@ -10850,8 +10850,8 @@
         </p:nvSpPr>
         <p:spPr>
           <a:xfrm>
-            <a:off x="914400" y="1463040"/>
-            <a:ext cx="10332720" cy="548640"/>
+            <a:off x="457200" y="1463040"/>
+            <a:ext cx="11247120" cy="548640"/>
           </a:xfrm>
           <a:prstGeom prst="roundRect">
             <a:avLst/>
@@ -10884,16 +10884,16 @@
           <a:p>
             <a:pPr algn="l">
               <a:spcBef>
-                <a:spcPts val="600"/>
-              </a:spcBef>
-              <a:defRPr sz="1400" b="1">
+                <a:spcPts val="800"/>
+              </a:spcBef>
+              <a:defRPr sz="1300" b="1">
                 <a:solidFill>
                   <a:srgbClr val="FFFFFF"/>
                 </a:solidFill>
               </a:defRPr>
             </a:pPr>
             <a:r>
-              <a:t>Field                                          Agent vs R1          Human R1 vs R2          Status</a:t>
+              <a:t>   Field                     Agent AC₁    Agent %       Human AC₁    Human %       Status             p-value (two-tailed)</a:t>
             </a:r>
           </a:p>
         </p:txBody>
@@ -10906,8 +10906,8 @@
         </p:nvSpPr>
         <p:spPr>
           <a:xfrm>
-            <a:off x="914400" y="2103120"/>
-            <a:ext cx="10332720" cy="594360"/>
+            <a:off x="457200" y="2103120"/>
+            <a:ext cx="11247120" cy="548640"/>
           </a:xfrm>
           <a:prstGeom prst="roundRect">
             <a:avLst/>
@@ -10950,8 +10950,8 @@
         </p:nvSpPr>
         <p:spPr>
           <a:xfrm>
-            <a:off x="1097280" y="2194560"/>
-            <a:ext cx="2743200" cy="457200"/>
+            <a:off x="640080" y="2176272"/>
+            <a:ext cx="2011680" cy="411480"/>
           </a:xfrm>
           <a:prstGeom prst="rect">
             <a:avLst/>
@@ -10963,7 +10963,7 @@
           <a:lstStyle/>
           <a:p>
             <a:pPr algn="l">
-              <a:defRPr sz="1600" b="1">
+              <a:defRPr sz="1500" b="1">
                 <a:solidFill>
                   <a:srgbClr val="0096D6"/>
                 </a:solidFill>
@@ -10977,112 +10977,66 @@
       </p:sp>
       <p:sp>
         <p:nvSpPr>
-          <p:cNvPr id="7" name="Rounded Rectangle 6"/>
-          <p:cNvSpPr/>
-          <p:nvPr/>
-        </p:nvSpPr>
-        <p:spPr>
-          <a:xfrm>
-            <a:off x="4389120" y="2212848"/>
-            <a:ext cx="2925165" cy="365760"/>
-          </a:xfrm>
-          <a:prstGeom prst="roundRect">
-            <a:avLst/>
-          </a:prstGeom>
-          <a:solidFill>
-            <a:srgbClr val="0096D6"/>
-          </a:solidFill>
-          <a:ln>
-            <a:noFill/>
-          </a:ln>
-          <a:effectLst/>
-        </p:spPr>
-        <p:style>
-          <a:lnRef idx="1">
-            <a:schemeClr val="accent1"/>
-          </a:lnRef>
-          <a:fillRef idx="3">
-            <a:schemeClr val="accent1"/>
-          </a:fillRef>
-          <a:effectRef idx="2">
-            <a:schemeClr val="accent1"/>
-          </a:effectRef>
-          <a:fontRef idx="minor">
-            <a:schemeClr val="lt1"/>
-          </a:fontRef>
-        </p:style>
-        <p:txBody>
-          <a:bodyPr rtlCol="0" anchor="ctr" wrap="square"/>
-          <a:lstStyle/>
-          <a:p>
-            <a:pPr algn="l">
-              <a:spcBef>
-                <a:spcPts val="400"/>
-              </a:spcBef>
-              <a:defRPr sz="1300" b="1">
-                <a:solidFill>
-                  <a:srgbClr val="FFFFFF"/>
-                </a:solidFill>
-              </a:defRPr>
-            </a:pPr>
-            <a:r>
-              <a:t>  91.4%</a:t>
-            </a:r>
-          </a:p>
-        </p:txBody>
-      </p:sp>
-      <p:sp>
-        <p:nvSpPr>
-          <p:cNvPr id="8" name="Rounded Rectangle 7"/>
-          <p:cNvSpPr/>
-          <p:nvPr/>
-        </p:nvSpPr>
-        <p:spPr>
-          <a:xfrm>
-            <a:off x="7772400" y="2212848"/>
-            <a:ext cx="2982772" cy="365760"/>
-          </a:xfrm>
-          <a:prstGeom prst="roundRect">
-            <a:avLst/>
-          </a:prstGeom>
-          <a:solidFill>
-            <a:srgbClr val="A0A0A0"/>
-          </a:solidFill>
-          <a:ln>
-            <a:noFill/>
-          </a:ln>
-          <a:effectLst/>
-        </p:spPr>
-        <p:style>
-          <a:lnRef idx="1">
-            <a:schemeClr val="accent1"/>
-          </a:lnRef>
-          <a:fillRef idx="3">
-            <a:schemeClr val="accent1"/>
-          </a:fillRef>
-          <a:effectRef idx="2">
-            <a:schemeClr val="accent1"/>
-          </a:effectRef>
-          <a:fontRef idx="minor">
-            <a:schemeClr val="lt1"/>
-          </a:fontRef>
-        </p:style>
-        <p:txBody>
-          <a:bodyPr rtlCol="0" anchor="ctr" wrap="square"/>
-          <a:lstStyle/>
-          <a:p>
-            <a:pPr algn="l">
-              <a:spcBef>
-                <a:spcPts val="400"/>
-              </a:spcBef>
-              <a:defRPr sz="1300" b="1">
-                <a:solidFill>
-                  <a:srgbClr val="FFFFFF"/>
-                </a:solidFill>
-              </a:defRPr>
-            </a:pPr>
-            <a:r>
-              <a:t>  93.2%</a:t>
+          <p:cNvPr id="7" name="TextBox 6"/>
+          <p:cNvSpPr txBox="1"/>
+          <p:nvPr/>
+        </p:nvSpPr>
+        <p:spPr>
+          <a:xfrm>
+            <a:off x="2743200" y="2176272"/>
+            <a:ext cx="1097280" cy="411480"/>
+          </a:xfrm>
+          <a:prstGeom prst="rect">
+            <a:avLst/>
+          </a:prstGeom>
+          <a:noFill/>
+        </p:spPr>
+        <p:txBody>
+          <a:bodyPr wrap="square"/>
+          <a:lstStyle/>
+          <a:p>
+            <a:pPr algn="ctr">
+              <a:defRPr sz="1400" b="1">
+                <a:solidFill>
+                  <a:srgbClr val="2D2D3F"/>
+                </a:solidFill>
+              </a:defRPr>
+            </a:pPr>
+            <a:r>
+              <a:t>0.903</a:t>
+            </a:r>
+          </a:p>
+        </p:txBody>
+      </p:sp>
+      <p:sp>
+        <p:nvSpPr>
+          <p:cNvPr id="8" name="TextBox 7"/>
+          <p:cNvSpPr txBox="1"/>
+          <p:nvPr/>
+        </p:nvSpPr>
+        <p:spPr>
+          <a:xfrm>
+            <a:off x="3931920" y="2176272"/>
+            <a:ext cx="1097280" cy="411480"/>
+          </a:xfrm>
+          <a:prstGeom prst="rect">
+            <a:avLst/>
+          </a:prstGeom>
+          <a:noFill/>
+        </p:spPr>
+        <p:txBody>
+          <a:bodyPr wrap="square"/>
+          <a:lstStyle/>
+          <a:p>
+            <a:pPr algn="ctr">
+              <a:defRPr sz="1400" b="0">
+                <a:solidFill>
+                  <a:srgbClr val="A0A0A0"/>
+                </a:solidFill>
+              </a:defRPr>
+            </a:pPr>
+            <a:r>
+              <a:t>91.4%</a:t>
             </a:r>
           </a:p>
         </p:txBody>
@@ -11095,8 +11049,8 @@
         </p:nvSpPr>
         <p:spPr>
           <a:xfrm>
-            <a:off x="10058400" y="2194560"/>
-            <a:ext cx="1371600" cy="457200"/>
+            <a:off x="5212080" y="2176272"/>
+            <a:ext cx="1097280" cy="411480"/>
           </a:xfrm>
           <a:prstGeom prst="rect">
             <a:avLst/>
@@ -11107,29 +11061,128 @@
           <a:bodyPr wrap="square"/>
           <a:lstStyle/>
           <a:p>
-            <a:pPr algn="l">
+            <a:pPr algn="ctr">
+              <a:defRPr sz="1400" b="1">
+                <a:solidFill>
+                  <a:srgbClr val="2D2D3F"/>
+                </a:solidFill>
+              </a:defRPr>
+            </a:pPr>
+            <a:r>
+              <a:t>0.919</a:t>
+            </a:r>
+          </a:p>
+        </p:txBody>
+      </p:sp>
+      <p:sp>
+        <p:nvSpPr>
+          <p:cNvPr id="10" name="TextBox 9"/>
+          <p:cNvSpPr txBox="1"/>
+          <p:nvPr/>
+        </p:nvSpPr>
+        <p:spPr>
+          <a:xfrm>
+            <a:off x="6400800" y="2176272"/>
+            <a:ext cx="1097280" cy="411480"/>
+          </a:xfrm>
+          <a:prstGeom prst="rect">
+            <a:avLst/>
+          </a:prstGeom>
+          <a:noFill/>
+        </p:spPr>
+        <p:txBody>
+          <a:bodyPr wrap="square"/>
+          <a:lstStyle/>
+          <a:p>
+            <a:pPr algn="ctr">
+              <a:defRPr sz="1400" b="0">
+                <a:solidFill>
+                  <a:srgbClr val="A0A0A0"/>
+                </a:solidFill>
+              </a:defRPr>
+            </a:pPr>
+            <a:r>
+              <a:t>93.2%</a:t>
+            </a:r>
+          </a:p>
+        </p:txBody>
+      </p:sp>
+      <p:sp>
+        <p:nvSpPr>
+          <p:cNvPr id="11" name="TextBox 10"/>
+          <p:cNvSpPr txBox="1"/>
+          <p:nvPr/>
+        </p:nvSpPr>
+        <p:spPr>
+          <a:xfrm>
+            <a:off x="7589520" y="2176272"/>
+            <a:ext cx="1645920" cy="411480"/>
+          </a:xfrm>
+          <a:prstGeom prst="rect">
+            <a:avLst/>
+          </a:prstGeom>
+          <a:noFill/>
+        </p:spPr>
+        <p:txBody>
+          <a:bodyPr wrap="square"/>
+          <a:lstStyle/>
+          <a:p>
+            <a:pPr algn="ctr">
+              <a:defRPr sz="1300" b="0">
+                <a:solidFill>
+                  <a:srgbClr val="A0A0A0"/>
+                </a:solidFill>
+              </a:defRPr>
+            </a:pPr>
+            <a:r>
+              <a:t>1.8pp gap</a:t>
+            </a:r>
+          </a:p>
+        </p:txBody>
+      </p:sp>
+      <p:sp>
+        <p:nvSpPr>
+          <p:cNvPr id="12" name="TextBox 11"/>
+          <p:cNvSpPr txBox="1"/>
+          <p:nvPr/>
+        </p:nvSpPr>
+        <p:spPr>
+          <a:xfrm>
+            <a:off x="9418320" y="2176272"/>
+            <a:ext cx="2103120" cy="411480"/>
+          </a:xfrm>
+          <a:prstGeom prst="rect">
+            <a:avLst/>
+          </a:prstGeom>
+          <a:noFill/>
+        </p:spPr>
+        <p:txBody>
+          <a:bodyPr wrap="square"/>
+          <a:lstStyle/>
+          <a:p>
+            <a:pPr algn="ctr">
               <a:defRPr sz="1200" b="0">
                 <a:solidFill>
-                  <a:srgbClr val="A0A0A0"/>
-                </a:solidFill>
-              </a:defRPr>
-            </a:pPr>
-            <a:r>
-              <a:t>1.8pp gap</a:t>
-            </a:r>
-          </a:p>
-        </p:txBody>
-      </p:sp>
-      <p:sp>
-        <p:nvSpPr>
-          <p:cNvPr id="10" name="Rounded Rectangle 9"/>
+                  <a:srgbClr val="00C9A7"/>
+                </a:solidFill>
+              </a:defRPr>
+            </a:pPr>
+            <a:r>
+              <a:t>p=0.82  Not significant</a:t>
+            </a:r>
+          </a:p>
+        </p:txBody>
+      </p:sp>
+      <p:sp>
+        <p:nvSpPr>
+          <p:cNvPr id="13" name="Rounded Rectangle 12"/>
           <p:cNvSpPr/>
           <p:nvPr/>
         </p:nvSpPr>
         <p:spPr>
           <a:xfrm>
-            <a:off x="914400" y="2788920"/>
-            <a:ext cx="10332720" cy="594360"/>
+            <a:off x="457200" y="2743200"/>
+            <a:ext cx="11247120" cy="548640"/>
           </a:xfrm>
           <a:prstGeom prst="roundRect">
             <a:avLst/>
@@ -11166,159 +11219,14 @@
       </p:sp>
       <p:sp>
         <p:nvSpPr>
-          <p:cNvPr id="11" name="TextBox 10"/>
-          <p:cNvSpPr txBox="1"/>
-          <p:nvPr/>
-        </p:nvSpPr>
-        <p:spPr>
-          <a:xfrm>
-            <a:off x="1097280" y="2880360"/>
-            <a:ext cx="2743200" cy="457200"/>
-          </a:xfrm>
-          <a:prstGeom prst="rect">
-            <a:avLst/>
-          </a:prstGeom>
-          <a:noFill/>
-        </p:spPr>
-        <p:txBody>
-          <a:bodyPr wrap="square"/>
-          <a:lstStyle/>
-          <a:p>
-            <a:pPr algn="l">
-              <a:defRPr sz="1600" b="1">
-                <a:solidFill>
-                  <a:srgbClr val="FF8C42"/>
-                </a:solidFill>
-              </a:defRPr>
-            </a:pPr>
-            <a:r>
-              <a:t>Delivery Mode</a:t>
-            </a:r>
-          </a:p>
-        </p:txBody>
-      </p:sp>
-      <p:sp>
-        <p:nvSpPr>
-          <p:cNvPr id="12" name="Rounded Rectangle 11"/>
-          <p:cNvSpPr/>
-          <p:nvPr/>
-        </p:nvSpPr>
-        <p:spPr>
-          <a:xfrm>
-            <a:off x="4389120" y="2898648"/>
-            <a:ext cx="2733141" cy="365760"/>
-          </a:xfrm>
-          <a:prstGeom prst="roundRect">
-            <a:avLst/>
-          </a:prstGeom>
-          <a:solidFill>
-            <a:srgbClr val="FF8C42"/>
-          </a:solidFill>
-          <a:ln>
-            <a:noFill/>
-          </a:ln>
-          <a:effectLst/>
-        </p:spPr>
-        <p:style>
-          <a:lnRef idx="1">
-            <a:schemeClr val="accent1"/>
-          </a:lnRef>
-          <a:fillRef idx="3">
-            <a:schemeClr val="accent1"/>
-          </a:fillRef>
-          <a:effectRef idx="2">
-            <a:schemeClr val="accent1"/>
-          </a:effectRef>
-          <a:fontRef idx="minor">
-            <a:schemeClr val="lt1"/>
-          </a:fontRef>
-        </p:style>
-        <p:txBody>
-          <a:bodyPr rtlCol="0" anchor="ctr" wrap="square"/>
-          <a:lstStyle/>
-          <a:p>
-            <a:pPr algn="l">
-              <a:spcBef>
-                <a:spcPts val="400"/>
-              </a:spcBef>
-              <a:defRPr sz="1300" b="1">
-                <a:solidFill>
-                  <a:srgbClr val="FFFFFF"/>
-                </a:solidFill>
-              </a:defRPr>
-            </a:pPr>
-            <a:r>
-              <a:t>  85.4%</a:t>
-            </a:r>
-          </a:p>
-        </p:txBody>
-      </p:sp>
-      <p:sp>
-        <p:nvSpPr>
-          <p:cNvPr id="13" name="Rounded Rectangle 12"/>
-          <p:cNvSpPr/>
-          <p:nvPr/>
-        </p:nvSpPr>
-        <p:spPr>
-          <a:xfrm>
-            <a:off x="7772400" y="2898648"/>
-            <a:ext cx="2845155" cy="365760"/>
-          </a:xfrm>
-          <a:prstGeom prst="roundRect">
-            <a:avLst/>
-          </a:prstGeom>
-          <a:solidFill>
-            <a:srgbClr val="A0A0A0"/>
-          </a:solidFill>
-          <a:ln>
-            <a:noFill/>
-          </a:ln>
-          <a:effectLst/>
-        </p:spPr>
-        <p:style>
-          <a:lnRef idx="1">
-            <a:schemeClr val="accent1"/>
-          </a:lnRef>
-          <a:fillRef idx="3">
-            <a:schemeClr val="accent1"/>
-          </a:fillRef>
-          <a:effectRef idx="2">
-            <a:schemeClr val="accent1"/>
-          </a:effectRef>
-          <a:fontRef idx="minor">
-            <a:schemeClr val="lt1"/>
-          </a:fontRef>
-        </p:style>
-        <p:txBody>
-          <a:bodyPr rtlCol="0" anchor="ctr" wrap="square"/>
-          <a:lstStyle/>
-          <a:p>
-            <a:pPr algn="l">
-              <a:spcBef>
-                <a:spcPts val="400"/>
-              </a:spcBef>
-              <a:defRPr sz="1300" b="1">
-                <a:solidFill>
-                  <a:srgbClr val="FFFFFF"/>
-                </a:solidFill>
-              </a:defRPr>
-            </a:pPr>
-            <a:r>
-              <a:t>  88.9%</a:t>
-            </a:r>
-          </a:p>
-        </p:txBody>
-      </p:sp>
-      <p:sp>
-        <p:nvSpPr>
           <p:cNvPr id="14" name="TextBox 13"/>
           <p:cNvSpPr txBox="1"/>
           <p:nvPr/>
         </p:nvSpPr>
         <p:spPr>
           <a:xfrm>
-            <a:off x="10058400" y="2880360"/>
-            <a:ext cx="1371600" cy="457200"/>
+            <a:off x="640080" y="2816352"/>
+            <a:ext cx="2011680" cy="411480"/>
           </a:xfrm>
           <a:prstGeom prst="rect">
             <a:avLst/>
@@ -11330,28 +11238,226 @@
           <a:lstStyle/>
           <a:p>
             <a:pPr algn="l">
+              <a:defRPr sz="1500" b="1">
+                <a:solidFill>
+                  <a:srgbClr val="FF8C42"/>
+                </a:solidFill>
+              </a:defRPr>
+            </a:pPr>
+            <a:r>
+              <a:t>Delivery Mode</a:t>
+            </a:r>
+          </a:p>
+        </p:txBody>
+      </p:sp>
+      <p:sp>
+        <p:nvSpPr>
+          <p:cNvPr id="15" name="TextBox 14"/>
+          <p:cNvSpPr txBox="1"/>
+          <p:nvPr/>
+        </p:nvSpPr>
+        <p:spPr>
+          <a:xfrm>
+            <a:off x="2743200" y="2816352"/>
+            <a:ext cx="1097280" cy="411480"/>
+          </a:xfrm>
+          <a:prstGeom prst="rect">
+            <a:avLst/>
+          </a:prstGeom>
+          <a:noFill/>
+        </p:spPr>
+        <p:txBody>
+          <a:bodyPr wrap="square"/>
+          <a:lstStyle/>
+          <a:p>
+            <a:pPr algn="ctr">
+              <a:defRPr sz="1400" b="1">
+                <a:solidFill>
+                  <a:srgbClr val="2D2D3F"/>
+                </a:solidFill>
+              </a:defRPr>
+            </a:pPr>
+            <a:r>
+              <a:t>0.835</a:t>
+            </a:r>
+          </a:p>
+        </p:txBody>
+      </p:sp>
+      <p:sp>
+        <p:nvSpPr>
+          <p:cNvPr id="16" name="TextBox 15"/>
+          <p:cNvSpPr txBox="1"/>
+          <p:nvPr/>
+        </p:nvSpPr>
+        <p:spPr>
+          <a:xfrm>
+            <a:off x="3931920" y="2816352"/>
+            <a:ext cx="1097280" cy="411480"/>
+          </a:xfrm>
+          <a:prstGeom prst="rect">
+            <a:avLst/>
+          </a:prstGeom>
+          <a:noFill/>
+        </p:spPr>
+        <p:txBody>
+          <a:bodyPr wrap="square"/>
+          <a:lstStyle/>
+          <a:p>
+            <a:pPr algn="ctr">
+              <a:defRPr sz="1400" b="0">
+                <a:solidFill>
+                  <a:srgbClr val="A0A0A0"/>
+                </a:solidFill>
+              </a:defRPr>
+            </a:pPr>
+            <a:r>
+              <a:t>85.4%</a:t>
+            </a:r>
+          </a:p>
+        </p:txBody>
+      </p:sp>
+      <p:sp>
+        <p:nvSpPr>
+          <p:cNvPr id="17" name="TextBox 16"/>
+          <p:cNvSpPr txBox="1"/>
+          <p:nvPr/>
+        </p:nvSpPr>
+        <p:spPr>
+          <a:xfrm>
+            <a:off x="5212080" y="2816352"/>
+            <a:ext cx="1097280" cy="411480"/>
+          </a:xfrm>
+          <a:prstGeom prst="rect">
+            <a:avLst/>
+          </a:prstGeom>
+          <a:noFill/>
+        </p:spPr>
+        <p:txBody>
+          <a:bodyPr wrap="square"/>
+          <a:lstStyle/>
+          <a:p>
+            <a:pPr algn="ctr">
+              <a:defRPr sz="1400" b="1">
+                <a:solidFill>
+                  <a:srgbClr val="2D2D3F"/>
+                </a:solidFill>
+              </a:defRPr>
+            </a:pPr>
+            <a:r>
+              <a:t>0.878</a:t>
+            </a:r>
+          </a:p>
+        </p:txBody>
+      </p:sp>
+      <p:sp>
+        <p:nvSpPr>
+          <p:cNvPr id="18" name="TextBox 17"/>
+          <p:cNvSpPr txBox="1"/>
+          <p:nvPr/>
+        </p:nvSpPr>
+        <p:spPr>
+          <a:xfrm>
+            <a:off x="6400800" y="2816352"/>
+            <a:ext cx="1097280" cy="411480"/>
+          </a:xfrm>
+          <a:prstGeom prst="rect">
+            <a:avLst/>
+          </a:prstGeom>
+          <a:noFill/>
+        </p:spPr>
+        <p:txBody>
+          <a:bodyPr wrap="square"/>
+          <a:lstStyle/>
+          <a:p>
+            <a:pPr algn="ctr">
+              <a:defRPr sz="1400" b="0">
+                <a:solidFill>
+                  <a:srgbClr val="A0A0A0"/>
+                </a:solidFill>
+              </a:defRPr>
+            </a:pPr>
+            <a:r>
+              <a:t>88.9%</a:t>
+            </a:r>
+          </a:p>
+        </p:txBody>
+      </p:sp>
+      <p:sp>
+        <p:nvSpPr>
+          <p:cNvPr id="19" name="TextBox 18"/>
+          <p:cNvSpPr txBox="1"/>
+          <p:nvPr/>
+        </p:nvSpPr>
+        <p:spPr>
+          <a:xfrm>
+            <a:off x="7589520" y="2816352"/>
+            <a:ext cx="1645920" cy="411480"/>
+          </a:xfrm>
+          <a:prstGeom prst="rect">
+            <a:avLst/>
+          </a:prstGeom>
+          <a:noFill/>
+        </p:spPr>
+        <p:txBody>
+          <a:bodyPr wrap="square"/>
+          <a:lstStyle/>
+          <a:p>
+            <a:pPr algn="ctr">
+              <a:defRPr sz="1300" b="0">
+                <a:solidFill>
+                  <a:srgbClr val="A0A0A0"/>
+                </a:solidFill>
+              </a:defRPr>
+            </a:pPr>
+            <a:r>
+              <a:t>3.5pp gap</a:t>
+            </a:r>
+          </a:p>
+        </p:txBody>
+      </p:sp>
+      <p:sp>
+        <p:nvSpPr>
+          <p:cNvPr id="20" name="TextBox 19"/>
+          <p:cNvSpPr txBox="1"/>
+          <p:nvPr/>
+        </p:nvSpPr>
+        <p:spPr>
+          <a:xfrm>
+            <a:off x="9418320" y="2816352"/>
+            <a:ext cx="2103120" cy="411480"/>
+          </a:xfrm>
+          <a:prstGeom prst="rect">
+            <a:avLst/>
+          </a:prstGeom>
+          <a:noFill/>
+        </p:spPr>
+        <p:txBody>
+          <a:bodyPr wrap="square"/>
+          <a:lstStyle/>
+          <a:p>
+            <a:pPr algn="ctr">
               <a:defRPr sz="1200" b="0">
                 <a:solidFill>
-                  <a:srgbClr val="A0A0A0"/>
-                </a:solidFill>
-              </a:defRPr>
-            </a:pPr>
-            <a:r>
-              <a:t>3.5pp gap</a:t>
-            </a:r>
-          </a:p>
-        </p:txBody>
-      </p:sp>
-      <p:sp>
-        <p:nvSpPr>
-          <p:cNvPr id="15" name="Rounded Rectangle 14"/>
+                  <a:srgbClr val="00C9A7"/>
+                </a:solidFill>
+              </a:defRPr>
+            </a:pPr>
+            <a:r>
+              <a:t>p=0.58  Not significant</a:t>
+            </a:r>
+          </a:p>
+        </p:txBody>
+      </p:sp>
+      <p:sp>
+        <p:nvSpPr>
+          <p:cNvPr id="21" name="Rounded Rectangle 20"/>
           <p:cNvSpPr/>
           <p:nvPr/>
         </p:nvSpPr>
         <p:spPr>
           <a:xfrm>
-            <a:off x="914400" y="3474720"/>
-            <a:ext cx="10332720" cy="594360"/>
+            <a:off x="457200" y="3383279"/>
+            <a:ext cx="11247120" cy="548640"/>
           </a:xfrm>
           <a:prstGeom prst="roundRect">
             <a:avLst/>
@@ -11388,14 +11494,14 @@
       </p:sp>
       <p:sp>
         <p:nvSpPr>
-          <p:cNvPr id="16" name="TextBox 15"/>
+          <p:cNvPr id="22" name="TextBox 21"/>
           <p:cNvSpPr txBox="1"/>
           <p:nvPr/>
         </p:nvSpPr>
         <p:spPr>
           <a:xfrm>
-            <a:off x="1097280" y="3566160"/>
-            <a:ext cx="2743200" cy="457200"/>
+            <a:off x="640080" y="3456431"/>
+            <a:ext cx="2011680" cy="411480"/>
           </a:xfrm>
           <a:prstGeom prst="rect">
             <a:avLst/>
@@ -11407,7 +11513,7 @@
           <a:lstStyle/>
           <a:p>
             <a:pPr algn="l">
-              <a:defRPr sz="1600" b="1">
+              <a:defRPr sz="1500" b="1">
                 <a:solidFill>
                   <a:srgbClr val="FF5C5C"/>
                 </a:solidFill>
@@ -11421,159 +11527,212 @@
       </p:sp>
       <p:sp>
         <p:nvSpPr>
-          <p:cNvPr id="17" name="Rounded Rectangle 16"/>
+          <p:cNvPr id="23" name="TextBox 22"/>
+          <p:cNvSpPr txBox="1"/>
+          <p:nvPr/>
+        </p:nvSpPr>
+        <p:spPr>
+          <a:xfrm>
+            <a:off x="2743200" y="3456431"/>
+            <a:ext cx="1097280" cy="411480"/>
+          </a:xfrm>
+          <a:prstGeom prst="rect">
+            <a:avLst/>
+          </a:prstGeom>
+          <a:noFill/>
+        </p:spPr>
+        <p:txBody>
+          <a:bodyPr wrap="square"/>
+          <a:lstStyle/>
+          <a:p>
+            <a:pPr algn="ctr">
+              <a:defRPr sz="1400" b="1">
+                <a:solidFill>
+                  <a:srgbClr val="2D2D3F"/>
+                </a:solidFill>
+              </a:defRPr>
+            </a:pPr>
+            <a:r>
+              <a:t>0.558</a:t>
+            </a:r>
+          </a:p>
+        </p:txBody>
+      </p:sp>
+      <p:sp>
+        <p:nvSpPr>
+          <p:cNvPr id="24" name="TextBox 23"/>
+          <p:cNvSpPr txBox="1"/>
+          <p:nvPr/>
+        </p:nvSpPr>
+        <p:spPr>
+          <a:xfrm>
+            <a:off x="3931920" y="3456431"/>
+            <a:ext cx="1097280" cy="411480"/>
+          </a:xfrm>
+          <a:prstGeom prst="rect">
+            <a:avLst/>
+          </a:prstGeom>
+          <a:noFill/>
+        </p:spPr>
+        <p:txBody>
+          <a:bodyPr wrap="square"/>
+          <a:lstStyle/>
+          <a:p>
+            <a:pPr algn="ctr">
+              <a:defRPr sz="1400" b="0">
+                <a:solidFill>
+                  <a:srgbClr val="A0A0A0"/>
+                </a:solidFill>
+              </a:defRPr>
+            </a:pPr>
+            <a:r>
+              <a:t>60.5%</a:t>
+            </a:r>
+          </a:p>
+        </p:txBody>
+      </p:sp>
+      <p:sp>
+        <p:nvSpPr>
+          <p:cNvPr id="25" name="TextBox 24"/>
+          <p:cNvSpPr txBox="1"/>
+          <p:nvPr/>
+        </p:nvSpPr>
+        <p:spPr>
+          <a:xfrm>
+            <a:off x="5212080" y="3456431"/>
+            <a:ext cx="1097280" cy="411480"/>
+          </a:xfrm>
+          <a:prstGeom prst="rect">
+            <a:avLst/>
+          </a:prstGeom>
+          <a:noFill/>
+        </p:spPr>
+        <p:txBody>
+          <a:bodyPr wrap="square"/>
+          <a:lstStyle/>
+          <a:p>
+            <a:pPr algn="ctr">
+              <a:defRPr sz="1400" b="1">
+                <a:solidFill>
+                  <a:srgbClr val="2D2D3F"/>
+                </a:solidFill>
+              </a:defRPr>
+            </a:pPr>
+            <a:r>
+              <a:t>0.583</a:t>
+            </a:r>
+          </a:p>
+        </p:txBody>
+      </p:sp>
+      <p:sp>
+        <p:nvSpPr>
+          <p:cNvPr id="26" name="TextBox 25"/>
+          <p:cNvSpPr txBox="1"/>
+          <p:nvPr/>
+        </p:nvSpPr>
+        <p:spPr>
+          <a:xfrm>
+            <a:off x="6400800" y="3456431"/>
+            <a:ext cx="1097280" cy="411480"/>
+          </a:xfrm>
+          <a:prstGeom prst="rect">
+            <a:avLst/>
+          </a:prstGeom>
+          <a:noFill/>
+        </p:spPr>
+        <p:txBody>
+          <a:bodyPr wrap="square"/>
+          <a:lstStyle/>
+          <a:p>
+            <a:pPr algn="ctr">
+              <a:defRPr sz="1400" b="0">
+                <a:solidFill>
+                  <a:srgbClr val="A0A0A0"/>
+                </a:solidFill>
+              </a:defRPr>
+            </a:pPr>
+            <a:r>
+              <a:t>64.3%</a:t>
+            </a:r>
+          </a:p>
+        </p:txBody>
+      </p:sp>
+      <p:sp>
+        <p:nvSpPr>
+          <p:cNvPr id="27" name="TextBox 26"/>
+          <p:cNvSpPr txBox="1"/>
+          <p:nvPr/>
+        </p:nvSpPr>
+        <p:spPr>
+          <a:xfrm>
+            <a:off x="7589520" y="3456431"/>
+            <a:ext cx="1645920" cy="411480"/>
+          </a:xfrm>
+          <a:prstGeom prst="rect">
+            <a:avLst/>
+          </a:prstGeom>
+          <a:noFill/>
+        </p:spPr>
+        <p:txBody>
+          <a:bodyPr wrap="square"/>
+          <a:lstStyle/>
+          <a:p>
+            <a:pPr algn="ctr">
+              <a:defRPr sz="1300" b="0">
+                <a:solidFill>
+                  <a:srgbClr val="A0A0A0"/>
+                </a:solidFill>
+              </a:defRPr>
+            </a:pPr>
+            <a:r>
+              <a:t>3.8pp gap</a:t>
+            </a:r>
+          </a:p>
+        </p:txBody>
+      </p:sp>
+      <p:sp>
+        <p:nvSpPr>
+          <p:cNvPr id="28" name="TextBox 27"/>
+          <p:cNvSpPr txBox="1"/>
+          <p:nvPr/>
+        </p:nvSpPr>
+        <p:spPr>
+          <a:xfrm>
+            <a:off x="9418320" y="3456431"/>
+            <a:ext cx="2103120" cy="411480"/>
+          </a:xfrm>
+          <a:prstGeom prst="rect">
+            <a:avLst/>
+          </a:prstGeom>
+          <a:noFill/>
+        </p:spPr>
+        <p:txBody>
+          <a:bodyPr wrap="square"/>
+          <a:lstStyle/>
+          <a:p>
+            <a:pPr algn="ctr">
+              <a:defRPr sz="1200" b="0">
+                <a:solidFill>
+                  <a:srgbClr val="00C9A7"/>
+                </a:solidFill>
+              </a:defRPr>
+            </a:pPr>
+            <a:r>
+              <a:t>p=0.77  Not significant</a:t>
+            </a:r>
+          </a:p>
+        </p:txBody>
+      </p:sp>
+      <p:sp>
+        <p:nvSpPr>
+          <p:cNvPr id="29" name="Rounded Rectangle 28"/>
           <p:cNvSpPr/>
           <p:nvPr/>
         </p:nvSpPr>
         <p:spPr>
           <a:xfrm>
-            <a:off x="4389120" y="3584448"/>
-            <a:ext cx="1936241" cy="365760"/>
-          </a:xfrm>
-          <a:prstGeom prst="roundRect">
-            <a:avLst/>
-          </a:prstGeom>
-          <a:solidFill>
-            <a:srgbClr val="FF5C5C"/>
-          </a:solidFill>
-          <a:ln>
-            <a:noFill/>
-          </a:ln>
-          <a:effectLst/>
-        </p:spPr>
-        <p:style>
-          <a:lnRef idx="1">
-            <a:schemeClr val="accent1"/>
-          </a:lnRef>
-          <a:fillRef idx="3">
-            <a:schemeClr val="accent1"/>
-          </a:fillRef>
-          <a:effectRef idx="2">
-            <a:schemeClr val="accent1"/>
-          </a:effectRef>
-          <a:fontRef idx="minor">
-            <a:schemeClr val="lt1"/>
-          </a:fontRef>
-        </p:style>
-        <p:txBody>
-          <a:bodyPr rtlCol="0" anchor="ctr" wrap="square"/>
-          <a:lstStyle/>
-          <a:p>
-            <a:pPr algn="l">
-              <a:spcBef>
-                <a:spcPts val="400"/>
-              </a:spcBef>
-              <a:defRPr sz="1300" b="1">
-                <a:solidFill>
-                  <a:srgbClr val="FFFFFF"/>
-                </a:solidFill>
-              </a:defRPr>
-            </a:pPr>
-            <a:r>
-              <a:t>  60.5%</a:t>
-            </a:r>
-          </a:p>
-        </p:txBody>
-      </p:sp>
-      <p:sp>
-        <p:nvSpPr>
-          <p:cNvPr id="18" name="Rounded Rectangle 17"/>
-          <p:cNvSpPr/>
-          <p:nvPr/>
-        </p:nvSpPr>
-        <p:spPr>
-          <a:xfrm>
-            <a:off x="7772400" y="3584448"/>
-            <a:ext cx="2057857" cy="365760"/>
-          </a:xfrm>
-          <a:prstGeom prst="roundRect">
-            <a:avLst/>
-          </a:prstGeom>
-          <a:solidFill>
-            <a:srgbClr val="A0A0A0"/>
-          </a:solidFill>
-          <a:ln>
-            <a:noFill/>
-          </a:ln>
-          <a:effectLst/>
-        </p:spPr>
-        <p:style>
-          <a:lnRef idx="1">
-            <a:schemeClr val="accent1"/>
-          </a:lnRef>
-          <a:fillRef idx="3">
-            <a:schemeClr val="accent1"/>
-          </a:fillRef>
-          <a:effectRef idx="2">
-            <a:schemeClr val="accent1"/>
-          </a:effectRef>
-          <a:fontRef idx="minor">
-            <a:schemeClr val="lt1"/>
-          </a:fontRef>
-        </p:style>
-        <p:txBody>
-          <a:bodyPr rtlCol="0" anchor="ctr" wrap="square"/>
-          <a:lstStyle/>
-          <a:p>
-            <a:pPr algn="l">
-              <a:spcBef>
-                <a:spcPts val="400"/>
-              </a:spcBef>
-              <a:defRPr sz="1300" b="1">
-                <a:solidFill>
-                  <a:srgbClr val="FFFFFF"/>
-                </a:solidFill>
-              </a:defRPr>
-            </a:pPr>
-            <a:r>
-              <a:t>  64.3%</a:t>
-            </a:r>
-          </a:p>
-        </p:txBody>
-      </p:sp>
-      <p:sp>
-        <p:nvSpPr>
-          <p:cNvPr id="19" name="TextBox 18"/>
-          <p:cNvSpPr txBox="1"/>
-          <p:nvPr/>
-        </p:nvSpPr>
-        <p:spPr>
-          <a:xfrm>
-            <a:off x="10058400" y="3566160"/>
-            <a:ext cx="1371600" cy="457200"/>
-          </a:xfrm>
-          <a:prstGeom prst="rect">
-            <a:avLst/>
-          </a:prstGeom>
-          <a:noFill/>
-        </p:spPr>
-        <p:txBody>
-          <a:bodyPr wrap="square"/>
-          <a:lstStyle/>
-          <a:p>
-            <a:pPr algn="l">
-              <a:defRPr sz="1200" b="0">
-                <a:solidFill>
-                  <a:srgbClr val="A0A0A0"/>
-                </a:solidFill>
-              </a:defRPr>
-            </a:pPr>
-            <a:r>
-              <a:t>3.8pp gap</a:t>
-            </a:r>
-          </a:p>
-        </p:txBody>
-      </p:sp>
-      <p:sp>
-        <p:nvSpPr>
-          <p:cNvPr id="20" name="Rounded Rectangle 19"/>
-          <p:cNvSpPr/>
-          <p:nvPr/>
-        </p:nvSpPr>
-        <p:spPr>
-          <a:xfrm>
-            <a:off x="914400" y="4160520"/>
-            <a:ext cx="10332720" cy="594360"/>
+            <a:off x="457200" y="4023359"/>
+            <a:ext cx="11247120" cy="548640"/>
           </a:xfrm>
           <a:prstGeom prst="roundRect">
             <a:avLst/>
@@ -11610,14 +11769,14 @@
       </p:sp>
       <p:sp>
         <p:nvSpPr>
-          <p:cNvPr id="21" name="TextBox 20"/>
+          <p:cNvPr id="30" name="TextBox 29"/>
           <p:cNvSpPr txBox="1"/>
           <p:nvPr/>
         </p:nvSpPr>
         <p:spPr>
           <a:xfrm>
-            <a:off x="1097280" y="4251960"/>
-            <a:ext cx="2743200" cy="457200"/>
+            <a:off x="640080" y="4096511"/>
+            <a:ext cx="2011680" cy="411480"/>
           </a:xfrm>
           <a:prstGeom prst="rect">
             <a:avLst/>
@@ -11629,7 +11788,7 @@
           <a:lstStyle/>
           <a:p>
             <a:pPr algn="l">
-              <a:defRPr sz="1600" b="1">
+              <a:defRPr sz="1500" b="1">
                 <a:solidFill>
                   <a:srgbClr val="A85CFF"/>
                 </a:solidFill>
@@ -11643,159 +11802,212 @@
       </p:sp>
       <p:sp>
         <p:nvSpPr>
-          <p:cNvPr id="22" name="Rounded Rectangle 21"/>
+          <p:cNvPr id="31" name="TextBox 30"/>
+          <p:cNvSpPr txBox="1"/>
+          <p:nvPr/>
+        </p:nvSpPr>
+        <p:spPr>
+          <a:xfrm>
+            <a:off x="2743200" y="4096511"/>
+            <a:ext cx="1097280" cy="411480"/>
+          </a:xfrm>
+          <a:prstGeom prst="rect">
+            <a:avLst/>
+          </a:prstGeom>
+          <a:noFill/>
+        </p:spPr>
+        <p:txBody>
+          <a:bodyPr wrap="square"/>
+          <a:lstStyle/>
+          <a:p>
+            <a:pPr algn="ctr">
+              <a:defRPr sz="1400" b="1">
+                <a:solidFill>
+                  <a:srgbClr val="2D2D3F"/>
+                </a:solidFill>
+              </a:defRPr>
+            </a:pPr>
+            <a:r>
+              <a:t>0.922</a:t>
+            </a:r>
+          </a:p>
+        </p:txBody>
+      </p:sp>
+      <p:sp>
+        <p:nvSpPr>
+          <p:cNvPr id="32" name="TextBox 31"/>
+          <p:cNvSpPr txBox="1"/>
+          <p:nvPr/>
+        </p:nvSpPr>
+        <p:spPr>
+          <a:xfrm>
+            <a:off x="3931920" y="4096511"/>
+            <a:ext cx="1097280" cy="411480"/>
+          </a:xfrm>
+          <a:prstGeom prst="rect">
+            <a:avLst/>
+          </a:prstGeom>
+          <a:noFill/>
+        </p:spPr>
+        <p:txBody>
+          <a:bodyPr wrap="square"/>
+          <a:lstStyle/>
+          <a:p>
+            <a:pPr algn="ctr">
+              <a:defRPr sz="1400" b="0">
+                <a:solidFill>
+                  <a:srgbClr val="A0A0A0"/>
+                </a:solidFill>
+              </a:defRPr>
+            </a:pPr>
+            <a:r>
+              <a:t>92.4%</a:t>
+            </a:r>
+          </a:p>
+        </p:txBody>
+      </p:sp>
+      <p:sp>
+        <p:nvSpPr>
+          <p:cNvPr id="33" name="TextBox 32"/>
+          <p:cNvSpPr txBox="1"/>
+          <p:nvPr/>
+        </p:nvSpPr>
+        <p:spPr>
+          <a:xfrm>
+            <a:off x="5212080" y="4096511"/>
+            <a:ext cx="1097280" cy="411480"/>
+          </a:xfrm>
+          <a:prstGeom prst="rect">
+            <a:avLst/>
+          </a:prstGeom>
+          <a:noFill/>
+        </p:spPr>
+        <p:txBody>
+          <a:bodyPr wrap="square"/>
+          <a:lstStyle/>
+          <a:p>
+            <a:pPr algn="ctr">
+              <a:defRPr sz="1400" b="1">
+                <a:solidFill>
+                  <a:srgbClr val="2D2D3F"/>
+                </a:solidFill>
+              </a:defRPr>
+            </a:pPr>
+            <a:r>
+              <a:t>0.881</a:t>
+            </a:r>
+          </a:p>
+        </p:txBody>
+      </p:sp>
+      <p:sp>
+        <p:nvSpPr>
+          <p:cNvPr id="34" name="TextBox 33"/>
+          <p:cNvSpPr txBox="1"/>
+          <p:nvPr/>
+        </p:nvSpPr>
+        <p:spPr>
+          <a:xfrm>
+            <a:off x="6400800" y="4096511"/>
+            <a:ext cx="1097280" cy="411480"/>
+          </a:xfrm>
+          <a:prstGeom prst="rect">
+            <a:avLst/>
+          </a:prstGeom>
+          <a:noFill/>
+        </p:spPr>
+        <p:txBody>
+          <a:bodyPr wrap="square"/>
+          <a:lstStyle/>
+          <a:p>
+            <a:pPr algn="ctr">
+              <a:defRPr sz="1400" b="0">
+                <a:solidFill>
+                  <a:srgbClr val="A0A0A0"/>
+                </a:solidFill>
+              </a:defRPr>
+            </a:pPr>
+            <a:r>
+              <a:t>88.6%</a:t>
+            </a:r>
+          </a:p>
+        </p:txBody>
+      </p:sp>
+      <p:sp>
+        <p:nvSpPr>
+          <p:cNvPr id="35" name="TextBox 34"/>
+          <p:cNvSpPr txBox="1"/>
+          <p:nvPr/>
+        </p:nvSpPr>
+        <p:spPr>
+          <a:xfrm>
+            <a:off x="7589520" y="4096511"/>
+            <a:ext cx="1645920" cy="411480"/>
+          </a:xfrm>
+          <a:prstGeom prst="rect">
+            <a:avLst/>
+          </a:prstGeom>
+          <a:noFill/>
+        </p:spPr>
+        <p:txBody>
+          <a:bodyPr wrap="square"/>
+          <a:lstStyle/>
+          <a:p>
+            <a:pPr algn="ctr">
+              <a:defRPr sz="1300" b="1">
+                <a:solidFill>
+                  <a:srgbClr val="00C9A7"/>
+                </a:solidFill>
+              </a:defRPr>
+            </a:pPr>
+            <a:r>
+              <a:t>Above human</a:t>
+            </a:r>
+          </a:p>
+        </p:txBody>
+      </p:sp>
+      <p:sp>
+        <p:nvSpPr>
+          <p:cNvPr id="36" name="TextBox 35"/>
+          <p:cNvSpPr txBox="1"/>
+          <p:nvPr/>
+        </p:nvSpPr>
+        <p:spPr>
+          <a:xfrm>
+            <a:off x="9418320" y="4096511"/>
+            <a:ext cx="2103120" cy="411480"/>
+          </a:xfrm>
+          <a:prstGeom prst="rect">
+            <a:avLst/>
+          </a:prstGeom>
+          <a:noFill/>
+        </p:spPr>
+        <p:txBody>
+          <a:bodyPr wrap="square"/>
+          <a:lstStyle/>
+          <a:p>
+            <a:pPr algn="ctr">
+              <a:defRPr sz="1200" b="0">
+                <a:solidFill>
+                  <a:srgbClr val="00C9A7"/>
+                </a:solidFill>
+              </a:defRPr>
+            </a:pPr>
+            <a:r>
+              <a:t>p=0.26  Not significant</a:t>
+            </a:r>
+          </a:p>
+        </p:txBody>
+      </p:sp>
+      <p:sp>
+        <p:nvSpPr>
+          <p:cNvPr id="37" name="Rounded Rectangle 36"/>
           <p:cNvSpPr/>
           <p:nvPr/>
         </p:nvSpPr>
         <p:spPr>
           <a:xfrm>
-            <a:off x="4389120" y="4270248"/>
-            <a:ext cx="2957169" cy="365760"/>
-          </a:xfrm>
-          <a:prstGeom prst="roundRect">
-            <a:avLst/>
-          </a:prstGeom>
-          <a:solidFill>
-            <a:srgbClr val="A85CFF"/>
-          </a:solidFill>
-          <a:ln>
-            <a:noFill/>
-          </a:ln>
-          <a:effectLst/>
-        </p:spPr>
-        <p:style>
-          <a:lnRef idx="1">
-            <a:schemeClr val="accent1"/>
-          </a:lnRef>
-          <a:fillRef idx="3">
-            <a:schemeClr val="accent1"/>
-          </a:fillRef>
-          <a:effectRef idx="2">
-            <a:schemeClr val="accent1"/>
-          </a:effectRef>
-          <a:fontRef idx="minor">
-            <a:schemeClr val="lt1"/>
-          </a:fontRef>
-        </p:style>
-        <p:txBody>
-          <a:bodyPr rtlCol="0" anchor="ctr" wrap="square"/>
-          <a:lstStyle/>
-          <a:p>
-            <a:pPr algn="l">
-              <a:spcBef>
-                <a:spcPts val="400"/>
-              </a:spcBef>
-              <a:defRPr sz="1300" b="1">
-                <a:solidFill>
-                  <a:srgbClr val="FFFFFF"/>
-                </a:solidFill>
-              </a:defRPr>
-            </a:pPr>
-            <a:r>
-              <a:t>  92.4%</a:t>
-            </a:r>
-          </a:p>
-        </p:txBody>
-      </p:sp>
-      <p:sp>
-        <p:nvSpPr>
-          <p:cNvPr id="23" name="Rounded Rectangle 22"/>
-          <p:cNvSpPr/>
-          <p:nvPr/>
-        </p:nvSpPr>
-        <p:spPr>
-          <a:xfrm>
-            <a:off x="7772400" y="4270248"/>
-            <a:ext cx="2835554" cy="365760"/>
-          </a:xfrm>
-          <a:prstGeom prst="roundRect">
-            <a:avLst/>
-          </a:prstGeom>
-          <a:solidFill>
-            <a:srgbClr val="A0A0A0"/>
-          </a:solidFill>
-          <a:ln>
-            <a:noFill/>
-          </a:ln>
-          <a:effectLst/>
-        </p:spPr>
-        <p:style>
-          <a:lnRef idx="1">
-            <a:schemeClr val="accent1"/>
-          </a:lnRef>
-          <a:fillRef idx="3">
-            <a:schemeClr val="accent1"/>
-          </a:fillRef>
-          <a:effectRef idx="2">
-            <a:schemeClr val="accent1"/>
-          </a:effectRef>
-          <a:fontRef idx="minor">
-            <a:schemeClr val="lt1"/>
-          </a:fontRef>
-        </p:style>
-        <p:txBody>
-          <a:bodyPr rtlCol="0" anchor="ctr" wrap="square"/>
-          <a:lstStyle/>
-          <a:p>
-            <a:pPr algn="l">
-              <a:spcBef>
-                <a:spcPts val="400"/>
-              </a:spcBef>
-              <a:defRPr sz="1300" b="1">
-                <a:solidFill>
-                  <a:srgbClr val="FFFFFF"/>
-                </a:solidFill>
-              </a:defRPr>
-            </a:pPr>
-            <a:r>
-              <a:t>  88.6%</a:t>
-            </a:r>
-          </a:p>
-        </p:txBody>
-      </p:sp>
-      <p:sp>
-        <p:nvSpPr>
-          <p:cNvPr id="24" name="TextBox 23"/>
-          <p:cNvSpPr txBox="1"/>
-          <p:nvPr/>
-        </p:nvSpPr>
-        <p:spPr>
-          <a:xfrm>
-            <a:off x="10058400" y="4251960"/>
-            <a:ext cx="1371600" cy="457200"/>
-          </a:xfrm>
-          <a:prstGeom prst="rect">
-            <a:avLst/>
-          </a:prstGeom>
-          <a:noFill/>
-        </p:spPr>
-        <p:txBody>
-          <a:bodyPr wrap="square"/>
-          <a:lstStyle/>
-          <a:p>
-            <a:pPr algn="l">
-              <a:defRPr sz="1200" b="1">
-                <a:solidFill>
-                  <a:srgbClr val="00C9A7"/>
-                </a:solidFill>
-              </a:defRPr>
-            </a:pPr>
-            <a:r>
-              <a:t>Above human</a:t>
-            </a:r>
-          </a:p>
-        </p:txBody>
-      </p:sp>
-      <p:sp>
-        <p:nvSpPr>
-          <p:cNvPr id="25" name="Rounded Rectangle 24"/>
-          <p:cNvSpPr/>
-          <p:nvPr/>
-        </p:nvSpPr>
-        <p:spPr>
-          <a:xfrm>
-            <a:off x="914400" y="4846320"/>
-            <a:ext cx="10332720" cy="594360"/>
+            <a:off x="457200" y="4663440"/>
+            <a:ext cx="11247120" cy="548640"/>
           </a:xfrm>
           <a:prstGeom prst="roundRect">
             <a:avLst/>
@@ -11832,14 +12044,14 @@
       </p:sp>
       <p:sp>
         <p:nvSpPr>
-          <p:cNvPr id="26" name="TextBox 25"/>
+          <p:cNvPr id="38" name="TextBox 37"/>
           <p:cNvSpPr txBox="1"/>
           <p:nvPr/>
         </p:nvSpPr>
         <p:spPr>
           <a:xfrm>
-            <a:off x="1097280" y="4937760"/>
-            <a:ext cx="2743200" cy="457200"/>
+            <a:off x="640080" y="4736592"/>
+            <a:ext cx="2011680" cy="411480"/>
           </a:xfrm>
           <a:prstGeom prst="rect">
             <a:avLst/>
@@ -11851,7 +12063,7 @@
           <a:lstStyle/>
           <a:p>
             <a:pPr algn="l">
-              <a:defRPr sz="1600" b="1">
+              <a:defRPr sz="1500" b="1">
                 <a:solidFill>
                   <a:srgbClr val="00C9A7"/>
                 </a:solidFill>
@@ -11865,159 +12077,212 @@
       </p:sp>
       <p:sp>
         <p:nvSpPr>
-          <p:cNvPr id="27" name="Rounded Rectangle 26"/>
+          <p:cNvPr id="39" name="TextBox 38"/>
+          <p:cNvSpPr txBox="1"/>
+          <p:nvPr/>
+        </p:nvSpPr>
+        <p:spPr>
+          <a:xfrm>
+            <a:off x="2743200" y="4736592"/>
+            <a:ext cx="1097280" cy="411480"/>
+          </a:xfrm>
+          <a:prstGeom prst="rect">
+            <a:avLst/>
+          </a:prstGeom>
+          <a:noFill/>
+        </p:spPr>
+        <p:txBody>
+          <a:bodyPr wrap="square"/>
+          <a:lstStyle/>
+          <a:p>
+            <a:pPr algn="ctr">
+              <a:defRPr sz="1400" b="1">
+                <a:solidFill>
+                  <a:srgbClr val="2D2D3F"/>
+                </a:solidFill>
+              </a:defRPr>
+            </a:pPr>
+            <a:r>
+              <a:t>0.826</a:t>
+            </a:r>
+          </a:p>
+        </p:txBody>
+      </p:sp>
+      <p:sp>
+        <p:nvSpPr>
+          <p:cNvPr id="40" name="TextBox 39"/>
+          <p:cNvSpPr txBox="1"/>
+          <p:nvPr/>
+        </p:nvSpPr>
+        <p:spPr>
+          <a:xfrm>
+            <a:off x="3931920" y="4736592"/>
+            <a:ext cx="1097280" cy="411480"/>
+          </a:xfrm>
+          <a:prstGeom prst="rect">
+            <a:avLst/>
+          </a:prstGeom>
+          <a:noFill/>
+        </p:spPr>
+        <p:txBody>
+          <a:bodyPr wrap="square"/>
+          <a:lstStyle/>
+          <a:p>
+            <a:pPr algn="ctr">
+              <a:defRPr sz="1400" b="0">
+                <a:solidFill>
+                  <a:srgbClr val="A0A0A0"/>
+                </a:solidFill>
+              </a:defRPr>
+            </a:pPr>
+            <a:r>
+              <a:t>88.3%</a:t>
+            </a:r>
+          </a:p>
+        </p:txBody>
+      </p:sp>
+      <p:sp>
+        <p:nvSpPr>
+          <p:cNvPr id="41" name="TextBox 40"/>
+          <p:cNvSpPr txBox="1"/>
+          <p:nvPr/>
+        </p:nvSpPr>
+        <p:spPr>
+          <a:xfrm>
+            <a:off x="5212080" y="4736592"/>
+            <a:ext cx="1097280" cy="411480"/>
+          </a:xfrm>
+          <a:prstGeom prst="rect">
+            <a:avLst/>
+          </a:prstGeom>
+          <a:noFill/>
+        </p:spPr>
+        <p:txBody>
+          <a:bodyPr wrap="square"/>
+          <a:lstStyle/>
+          <a:p>
+            <a:pPr algn="ctr">
+              <a:defRPr sz="1400" b="1">
+                <a:solidFill>
+                  <a:srgbClr val="2D2D3F"/>
+                </a:solidFill>
+              </a:defRPr>
+            </a:pPr>
+            <a:r>
+              <a:t>0.792</a:t>
+            </a:r>
+          </a:p>
+        </p:txBody>
+      </p:sp>
+      <p:sp>
+        <p:nvSpPr>
+          <p:cNvPr id="42" name="TextBox 41"/>
+          <p:cNvSpPr txBox="1"/>
+          <p:nvPr/>
+        </p:nvSpPr>
+        <p:spPr>
+          <a:xfrm>
+            <a:off x="6400800" y="4736592"/>
+            <a:ext cx="1097280" cy="411480"/>
+          </a:xfrm>
+          <a:prstGeom prst="rect">
+            <a:avLst/>
+          </a:prstGeom>
+          <a:noFill/>
+        </p:spPr>
+        <p:txBody>
+          <a:bodyPr wrap="square"/>
+          <a:lstStyle/>
+          <a:p>
+            <a:pPr algn="ctr">
+              <a:defRPr sz="1400" b="0">
+                <a:solidFill>
+                  <a:srgbClr val="A0A0A0"/>
+                </a:solidFill>
+              </a:defRPr>
+            </a:pPr>
+            <a:r>
+              <a:t>86.0%</a:t>
+            </a:r>
+          </a:p>
+        </p:txBody>
+      </p:sp>
+      <p:sp>
+        <p:nvSpPr>
+          <p:cNvPr id="43" name="TextBox 42"/>
+          <p:cNvSpPr txBox="1"/>
+          <p:nvPr/>
+        </p:nvSpPr>
+        <p:spPr>
+          <a:xfrm>
+            <a:off x="7589520" y="4736592"/>
+            <a:ext cx="1645920" cy="411480"/>
+          </a:xfrm>
+          <a:prstGeom prst="rect">
+            <a:avLst/>
+          </a:prstGeom>
+          <a:noFill/>
+        </p:spPr>
+        <p:txBody>
+          <a:bodyPr wrap="square"/>
+          <a:lstStyle/>
+          <a:p>
+            <a:pPr algn="ctr">
+              <a:defRPr sz="1300" b="1">
+                <a:solidFill>
+                  <a:srgbClr val="00C9A7"/>
+                </a:solidFill>
+              </a:defRPr>
+            </a:pPr>
+            <a:r>
+              <a:t>Above human</a:t>
+            </a:r>
+          </a:p>
+        </p:txBody>
+      </p:sp>
+      <p:sp>
+        <p:nvSpPr>
+          <p:cNvPr id="44" name="TextBox 43"/>
+          <p:cNvSpPr txBox="1"/>
+          <p:nvPr/>
+        </p:nvSpPr>
+        <p:spPr>
+          <a:xfrm>
+            <a:off x="9418320" y="4736592"/>
+            <a:ext cx="2103120" cy="411480"/>
+          </a:xfrm>
+          <a:prstGeom prst="rect">
+            <a:avLst/>
+          </a:prstGeom>
+          <a:noFill/>
+        </p:spPr>
+        <p:txBody>
+          <a:bodyPr wrap="square"/>
+          <a:lstStyle/>
+          <a:p>
+            <a:pPr algn="ctr">
+              <a:defRPr sz="1200" b="0">
+                <a:solidFill>
+                  <a:srgbClr val="00C9A7"/>
+                </a:solidFill>
+              </a:defRPr>
+            </a:pPr>
+            <a:r>
+              <a:t>p=0.76  Not significant</a:t>
+            </a:r>
+          </a:p>
+        </p:txBody>
+      </p:sp>
+      <p:sp>
+        <p:nvSpPr>
+          <p:cNvPr id="45" name="Rounded Rectangle 44"/>
           <p:cNvSpPr/>
           <p:nvPr/>
         </p:nvSpPr>
         <p:spPr>
           <a:xfrm>
-            <a:off x="4389120" y="4956048"/>
-            <a:ext cx="2825953" cy="365760"/>
-          </a:xfrm>
-          <a:prstGeom prst="roundRect">
-            <a:avLst/>
-          </a:prstGeom>
-          <a:solidFill>
-            <a:srgbClr val="00C9A7"/>
-          </a:solidFill>
-          <a:ln>
-            <a:noFill/>
-          </a:ln>
-          <a:effectLst/>
-        </p:spPr>
-        <p:style>
-          <a:lnRef idx="1">
-            <a:schemeClr val="accent1"/>
-          </a:lnRef>
-          <a:fillRef idx="3">
-            <a:schemeClr val="accent1"/>
-          </a:fillRef>
-          <a:effectRef idx="2">
-            <a:schemeClr val="accent1"/>
-          </a:effectRef>
-          <a:fontRef idx="minor">
-            <a:schemeClr val="lt1"/>
-          </a:fontRef>
-        </p:style>
-        <p:txBody>
-          <a:bodyPr rtlCol="0" anchor="ctr" wrap="square"/>
-          <a:lstStyle/>
-          <a:p>
-            <a:pPr algn="l">
-              <a:spcBef>
-                <a:spcPts val="400"/>
-              </a:spcBef>
-              <a:defRPr sz="1300" b="1">
-                <a:solidFill>
-                  <a:srgbClr val="FFFFFF"/>
-                </a:solidFill>
-              </a:defRPr>
-            </a:pPr>
-            <a:r>
-              <a:t>  88.3%</a:t>
-            </a:r>
-          </a:p>
-        </p:txBody>
-      </p:sp>
-      <p:sp>
-        <p:nvSpPr>
-          <p:cNvPr id="28" name="Rounded Rectangle 27"/>
-          <p:cNvSpPr/>
-          <p:nvPr/>
-        </p:nvSpPr>
-        <p:spPr>
-          <a:xfrm>
-            <a:off x="7772400" y="4956048"/>
-            <a:ext cx="2752344" cy="365760"/>
-          </a:xfrm>
-          <a:prstGeom prst="roundRect">
-            <a:avLst/>
-          </a:prstGeom>
-          <a:solidFill>
-            <a:srgbClr val="A0A0A0"/>
-          </a:solidFill>
-          <a:ln>
-            <a:noFill/>
-          </a:ln>
-          <a:effectLst/>
-        </p:spPr>
-        <p:style>
-          <a:lnRef idx="1">
-            <a:schemeClr val="accent1"/>
-          </a:lnRef>
-          <a:fillRef idx="3">
-            <a:schemeClr val="accent1"/>
-          </a:fillRef>
-          <a:effectRef idx="2">
-            <a:schemeClr val="accent1"/>
-          </a:effectRef>
-          <a:fontRef idx="minor">
-            <a:schemeClr val="lt1"/>
-          </a:fontRef>
-        </p:style>
-        <p:txBody>
-          <a:bodyPr rtlCol="0" anchor="ctr" wrap="square"/>
-          <a:lstStyle/>
-          <a:p>
-            <a:pPr algn="l">
-              <a:spcBef>
-                <a:spcPts val="400"/>
-              </a:spcBef>
-              <a:defRPr sz="1300" b="1">
-                <a:solidFill>
-                  <a:srgbClr val="FFFFFF"/>
-                </a:solidFill>
-              </a:defRPr>
-            </a:pPr>
-            <a:r>
-              <a:t>  86.0%</a:t>
-            </a:r>
-          </a:p>
-        </p:txBody>
-      </p:sp>
-      <p:sp>
-        <p:nvSpPr>
-          <p:cNvPr id="29" name="TextBox 28"/>
-          <p:cNvSpPr txBox="1"/>
-          <p:nvPr/>
-        </p:nvSpPr>
-        <p:spPr>
-          <a:xfrm>
-            <a:off x="10058400" y="4937760"/>
-            <a:ext cx="1371600" cy="457200"/>
-          </a:xfrm>
-          <a:prstGeom prst="rect">
-            <a:avLst/>
-          </a:prstGeom>
-          <a:noFill/>
-        </p:spPr>
-        <p:txBody>
-          <a:bodyPr wrap="square"/>
-          <a:lstStyle/>
-          <a:p>
-            <a:pPr algn="l">
-              <a:defRPr sz="1200" b="1">
-                <a:solidFill>
-                  <a:srgbClr val="00C9A7"/>
-                </a:solidFill>
-              </a:defRPr>
-            </a:pPr>
-            <a:r>
-              <a:t>Above human</a:t>
-            </a:r>
-          </a:p>
-        </p:txBody>
-      </p:sp>
-      <p:sp>
-        <p:nvSpPr>
-          <p:cNvPr id="30" name="Rounded Rectangle 29"/>
-          <p:cNvSpPr/>
-          <p:nvPr/>
-        </p:nvSpPr>
-        <p:spPr>
-          <a:xfrm>
-            <a:off x="914400" y="5532120"/>
-            <a:ext cx="10332720" cy="594360"/>
+            <a:off x="457200" y="5303520"/>
+            <a:ext cx="11247120" cy="548640"/>
           </a:xfrm>
           <a:prstGeom prst="roundRect">
             <a:avLst/>
@@ -12054,14 +12319,14 @@
       </p:sp>
       <p:sp>
         <p:nvSpPr>
-          <p:cNvPr id="31" name="TextBox 30"/>
+          <p:cNvPr id="46" name="TextBox 45"/>
           <p:cNvSpPr txBox="1"/>
           <p:nvPr/>
         </p:nvSpPr>
         <p:spPr>
           <a:xfrm>
-            <a:off x="1097280" y="5623560"/>
-            <a:ext cx="2743200" cy="457200"/>
+            <a:off x="640080" y="5376672"/>
+            <a:ext cx="2011680" cy="411480"/>
           </a:xfrm>
           <a:prstGeom prst="rect">
             <a:avLst/>
@@ -12073,7 +12338,7 @@
           <a:lstStyle/>
           <a:p>
             <a:pPr algn="l">
-              <a:defRPr sz="1600" b="1">
+              <a:defRPr sz="1500" b="1">
                 <a:solidFill>
                   <a:srgbClr val="0096D6"/>
                 </a:solidFill>
@@ -12087,126 +12352,179 @@
       </p:sp>
       <p:sp>
         <p:nvSpPr>
-          <p:cNvPr id="32" name="Rounded Rectangle 31"/>
-          <p:cNvSpPr/>
-          <p:nvPr/>
-        </p:nvSpPr>
-        <p:spPr>
-          <a:xfrm>
-            <a:off x="4389120" y="5641848"/>
-            <a:ext cx="1865833" cy="365760"/>
-          </a:xfrm>
-          <a:prstGeom prst="roundRect">
-            <a:avLst/>
-          </a:prstGeom>
-          <a:solidFill>
-            <a:srgbClr val="0096D6"/>
-          </a:solidFill>
-          <a:ln>
-            <a:noFill/>
-          </a:ln>
-          <a:effectLst/>
-        </p:spPr>
-        <p:style>
-          <a:lnRef idx="1">
-            <a:schemeClr val="accent1"/>
-          </a:lnRef>
-          <a:fillRef idx="3">
-            <a:schemeClr val="accent1"/>
-          </a:fillRef>
-          <a:effectRef idx="2">
-            <a:schemeClr val="accent1"/>
-          </a:effectRef>
-          <a:fontRef idx="minor">
-            <a:schemeClr val="lt1"/>
-          </a:fontRef>
-        </p:style>
-        <p:txBody>
-          <a:bodyPr rtlCol="0" anchor="ctr" wrap="square"/>
-          <a:lstStyle/>
-          <a:p>
-            <a:pPr algn="l">
-              <a:spcBef>
-                <a:spcPts val="400"/>
-              </a:spcBef>
+          <p:cNvPr id="47" name="TextBox 46"/>
+          <p:cNvSpPr txBox="1"/>
+          <p:nvPr/>
+        </p:nvSpPr>
+        <p:spPr>
+          <a:xfrm>
+            <a:off x="2743200" y="5376672"/>
+            <a:ext cx="1097280" cy="411480"/>
+          </a:xfrm>
+          <a:prstGeom prst="rect">
+            <a:avLst/>
+          </a:prstGeom>
+          <a:noFill/>
+        </p:spPr>
+        <p:txBody>
+          <a:bodyPr wrap="square"/>
+          <a:lstStyle/>
+          <a:p>
+            <a:pPr algn="ctr">
+              <a:defRPr sz="1400" b="1">
+                <a:solidFill>
+                  <a:srgbClr val="2D2D3F"/>
+                </a:solidFill>
+              </a:defRPr>
+            </a:pPr>
+            <a:r>
+              <a:t>0.566</a:t>
+            </a:r>
+          </a:p>
+        </p:txBody>
+      </p:sp>
+      <p:sp>
+        <p:nvSpPr>
+          <p:cNvPr id="48" name="TextBox 47"/>
+          <p:cNvSpPr txBox="1"/>
+          <p:nvPr/>
+        </p:nvSpPr>
+        <p:spPr>
+          <a:xfrm>
+            <a:off x="3931920" y="5376672"/>
+            <a:ext cx="1097280" cy="411480"/>
+          </a:xfrm>
+          <a:prstGeom prst="rect">
+            <a:avLst/>
+          </a:prstGeom>
+          <a:noFill/>
+        </p:spPr>
+        <p:txBody>
+          <a:bodyPr wrap="square"/>
+          <a:lstStyle/>
+          <a:p>
+            <a:pPr algn="ctr">
+              <a:defRPr sz="1400" b="0">
+                <a:solidFill>
+                  <a:srgbClr val="A0A0A0"/>
+                </a:solidFill>
+              </a:defRPr>
+            </a:pPr>
+            <a:r>
+              <a:t>58.3%</a:t>
+            </a:r>
+          </a:p>
+        </p:txBody>
+      </p:sp>
+      <p:sp>
+        <p:nvSpPr>
+          <p:cNvPr id="49" name="TextBox 48"/>
+          <p:cNvSpPr txBox="1"/>
+          <p:nvPr/>
+        </p:nvSpPr>
+        <p:spPr>
+          <a:xfrm>
+            <a:off x="5212080" y="5376672"/>
+            <a:ext cx="1097280" cy="411480"/>
+          </a:xfrm>
+          <a:prstGeom prst="rect">
+            <a:avLst/>
+          </a:prstGeom>
+          <a:noFill/>
+        </p:spPr>
+        <p:txBody>
+          <a:bodyPr wrap="square"/>
+          <a:lstStyle/>
+          <a:p>
+            <a:pPr algn="ctr">
+              <a:defRPr sz="1400" b="1">
+                <a:solidFill>
+                  <a:srgbClr val="2D2D3F"/>
+                </a:solidFill>
+              </a:defRPr>
+            </a:pPr>
+            <a:r>
+              <a:t>0.518</a:t>
+            </a:r>
+          </a:p>
+        </p:txBody>
+      </p:sp>
+      <p:sp>
+        <p:nvSpPr>
+          <p:cNvPr id="50" name="TextBox 49"/>
+          <p:cNvSpPr txBox="1"/>
+          <p:nvPr/>
+        </p:nvSpPr>
+        <p:spPr>
+          <a:xfrm>
+            <a:off x="6400800" y="5376672"/>
+            <a:ext cx="1097280" cy="411480"/>
+          </a:xfrm>
+          <a:prstGeom prst="rect">
+            <a:avLst/>
+          </a:prstGeom>
+          <a:noFill/>
+        </p:spPr>
+        <p:txBody>
+          <a:bodyPr wrap="square"/>
+          <a:lstStyle/>
+          <a:p>
+            <a:pPr algn="ctr">
+              <a:defRPr sz="1400" b="0">
+                <a:solidFill>
+                  <a:srgbClr val="A0A0A0"/>
+                </a:solidFill>
+              </a:defRPr>
+            </a:pPr>
+            <a:r>
+              <a:t>52.0%</a:t>
+            </a:r>
+          </a:p>
+        </p:txBody>
+      </p:sp>
+      <p:sp>
+        <p:nvSpPr>
+          <p:cNvPr id="51" name="TextBox 50"/>
+          <p:cNvSpPr txBox="1"/>
+          <p:nvPr/>
+        </p:nvSpPr>
+        <p:spPr>
+          <a:xfrm>
+            <a:off x="7589520" y="5376672"/>
+            <a:ext cx="1645920" cy="411480"/>
+          </a:xfrm>
+          <a:prstGeom prst="rect">
+            <a:avLst/>
+          </a:prstGeom>
+          <a:noFill/>
+        </p:spPr>
+        <p:txBody>
+          <a:bodyPr wrap="square"/>
+          <a:lstStyle/>
+          <a:p>
+            <a:pPr algn="ctr">
               <a:defRPr sz="1300" b="1">
                 <a:solidFill>
-                  <a:srgbClr val="FFFFFF"/>
-                </a:solidFill>
-              </a:defRPr>
-            </a:pPr>
-            <a:r>
-              <a:t>  58.3%</a:t>
-            </a:r>
-          </a:p>
-        </p:txBody>
-      </p:sp>
-      <p:sp>
-        <p:nvSpPr>
-          <p:cNvPr id="33" name="Rounded Rectangle 32"/>
-          <p:cNvSpPr/>
-          <p:nvPr/>
-        </p:nvSpPr>
-        <p:spPr>
-          <a:xfrm>
-            <a:off x="7772400" y="5641848"/>
-            <a:ext cx="1664208" cy="365760"/>
-          </a:xfrm>
-          <a:prstGeom prst="roundRect">
-            <a:avLst/>
-          </a:prstGeom>
-          <a:solidFill>
-            <a:srgbClr val="A0A0A0"/>
-          </a:solidFill>
-          <a:ln>
-            <a:noFill/>
-          </a:ln>
-          <a:effectLst/>
-        </p:spPr>
-        <p:style>
-          <a:lnRef idx="1">
-            <a:schemeClr val="accent1"/>
-          </a:lnRef>
-          <a:fillRef idx="3">
-            <a:schemeClr val="accent1"/>
-          </a:fillRef>
-          <a:effectRef idx="2">
-            <a:schemeClr val="accent1"/>
-          </a:effectRef>
-          <a:fontRef idx="minor">
-            <a:schemeClr val="lt1"/>
-          </a:fontRef>
-        </p:style>
-        <p:txBody>
-          <a:bodyPr rtlCol="0" anchor="ctr" wrap="square"/>
-          <a:lstStyle/>
-          <a:p>
-            <a:pPr algn="l">
-              <a:spcBef>
-                <a:spcPts val="400"/>
-              </a:spcBef>
-              <a:defRPr sz="1300" b="1">
-                <a:solidFill>
-                  <a:srgbClr val="FFFFFF"/>
-                </a:solidFill>
-              </a:defRPr>
-            </a:pPr>
-            <a:r>
-              <a:t>  52.0%</a:t>
-            </a:r>
-          </a:p>
-        </p:txBody>
-      </p:sp>
-      <p:sp>
-        <p:nvSpPr>
-          <p:cNvPr id="34" name="TextBox 33"/>
+                  <a:srgbClr val="00C9A7"/>
+                </a:solidFill>
+              </a:defRPr>
+            </a:pPr>
+            <a:r>
+              <a:t>Above human</a:t>
+            </a:r>
+          </a:p>
+        </p:txBody>
+      </p:sp>
+      <p:sp>
+        <p:nvSpPr>
+          <p:cNvPr id="52" name="TextBox 51"/>
           <p:cNvSpPr txBox="1"/>
           <p:nvPr/>
         </p:nvSpPr>
         <p:spPr>
           <a:xfrm>
-            <a:off x="10058400" y="5623560"/>
-            <a:ext cx="1371600" cy="457200"/>
+            <a:off x="9418320" y="5376672"/>
+            <a:ext cx="2103120" cy="411480"/>
           </a:xfrm>
           <a:prstGeom prst="rect">
             <a:avLst/>
@@ -12217,29 +12535,29 @@
           <a:bodyPr wrap="square"/>
           <a:lstStyle/>
           <a:p>
-            <a:pPr algn="l">
-              <a:defRPr sz="1200" b="1">
+            <a:pPr algn="ctr">
+              <a:defRPr sz="1200" b="0">
                 <a:solidFill>
                   <a:srgbClr val="00C9A7"/>
                 </a:solidFill>
               </a:defRPr>
             </a:pPr>
             <a:r>
-              <a:t>Above human</a:t>
-            </a:r>
-          </a:p>
-        </p:txBody>
-      </p:sp>
-      <p:sp>
-        <p:nvSpPr>
-          <p:cNvPr id="35" name="TextBox 34"/>
+              <a:t>p=0.41  Not significant</a:t>
+            </a:r>
+          </a:p>
+        </p:txBody>
+      </p:sp>
+      <p:sp>
+        <p:nvSpPr>
+          <p:cNvPr id="53" name="TextBox 52"/>
           <p:cNvSpPr txBox="1"/>
           <p:nvPr/>
         </p:nvSpPr>
         <p:spPr>
           <a:xfrm>
-            <a:off x="4389120" y="6217920"/>
-            <a:ext cx="7315200" cy="365760"/>
+            <a:off x="457200" y="6035040"/>
+            <a:ext cx="11247120" cy="640080"/>
           </a:xfrm>
           <a:prstGeom prst="rect">
             <a:avLst/>
@@ -12258,7 +12576,22 @@
               </a:defRPr>
             </a:pPr>
             <a:r>
-              <a:t>          Agent vs R1                                              Human R1 vs R2</a:t>
+              <a:t>Statistical test: Two-tailed z-test on AC₁ difference (SE derived from 95% CI). α = 0.05.</a:t>
+            </a:r>
+          </a:p>
+          <a:p>
+            <a:pPr>
+              <a:spcBef>
+                <a:spcPts val="400"/>
+              </a:spcBef>
+              <a:defRPr sz="1300" b="1">
+                <a:solidFill>
+                  <a:srgbClr val="2D2D3F"/>
+                </a:solidFill>
+              </a:defRPr>
+            </a:pPr>
+            <a:r>
+              <a:t>No field shows a statistically significant difference between agent and human agreement — the agent performs at human-level across all 6 fields.</a:t>
             </a:r>
           </a:p>
         </p:txBody>

</xml_diff>

<commit_message>
feat: separate p-values for Agent-R1 and Agent-R2, directional significance
- Two p-value columns: agent vs R1 and agent vs R2, each compared to R1 vs R2
- Significance shows direction: "sig. better" (green) or "sig. worse" (red)
- PPT updated with both comparisons + interpretation column
</commit_message>
<xml_diff>
--- a/amp_llm_v3/standalone modules/agent_annotate/docs/Agent_Annotate_Architecture.pptx
+++ b/amp_llm_v3/standalone modules/agent_annotate/docs/Agent_Annotate_Architecture.pptx
@@ -10850,8 +10850,8 @@
         </p:nvSpPr>
         <p:spPr>
           <a:xfrm>
-            <a:off x="457200" y="1463040"/>
-            <a:ext cx="11247120" cy="548640"/>
+            <a:off x="274320" y="1463040"/>
+            <a:ext cx="11612880" cy="548640"/>
           </a:xfrm>
           <a:prstGeom prst="roundRect">
             <a:avLst/>
@@ -10886,14 +10886,14 @@
               <a:spcBef>
                 <a:spcPts val="800"/>
               </a:spcBef>
-              <a:defRPr sz="1300" b="1">
+              <a:defRPr sz="1200" b="1">
                 <a:solidFill>
                   <a:srgbClr val="FFFFFF"/>
                 </a:solidFill>
               </a:defRPr>
             </a:pPr>
             <a:r>
-              <a:t>   Field                     Agent AC₁    Agent %       Human AC₁    Human %       Status             p-value (two-tailed)</a:t>
+              <a:t>   Field                  Agent–R1 AC₁  Agent–R2 AC₁  Human AC₁      p (R1)              p (R2)              Interpretation</a:t>
             </a:r>
           </a:p>
         </p:txBody>
@@ -10906,8 +10906,8 @@
         </p:nvSpPr>
         <p:spPr>
           <a:xfrm>
-            <a:off x="457200" y="2103120"/>
-            <a:ext cx="11247120" cy="548640"/>
+            <a:off x="274320" y="2103120"/>
+            <a:ext cx="11612880" cy="548640"/>
           </a:xfrm>
           <a:prstGeom prst="roundRect">
             <a:avLst/>
@@ -10950,8 +10950,8 @@
         </p:nvSpPr>
         <p:spPr>
           <a:xfrm>
-            <a:off x="640080" y="2176272"/>
-            <a:ext cx="2011680" cy="411480"/>
+            <a:off x="457200" y="2176272"/>
+            <a:ext cx="1828800" cy="411480"/>
           </a:xfrm>
           <a:prstGeom prst="rect">
             <a:avLst/>
@@ -10963,7 +10963,7 @@
           <a:lstStyle/>
           <a:p>
             <a:pPr algn="l">
-              <a:defRPr sz="1500" b="1">
+              <a:defRPr sz="1400" b="1">
                 <a:solidFill>
                   <a:srgbClr val="0096D6"/>
                 </a:solidFill>
@@ -10983,8 +10983,8 @@
         </p:nvSpPr>
         <p:spPr>
           <a:xfrm>
-            <a:off x="2743200" y="2176272"/>
-            <a:ext cx="1097280" cy="411480"/>
+            <a:off x="2377440" y="2176272"/>
+            <a:ext cx="1188720" cy="411480"/>
           </a:xfrm>
           <a:prstGeom prst="rect">
             <a:avLst/>
@@ -10996,14 +10996,14 @@
           <a:lstStyle/>
           <a:p>
             <a:pPr algn="ctr">
-              <a:defRPr sz="1400" b="1">
-                <a:solidFill>
-                  <a:srgbClr val="2D2D3F"/>
-                </a:solidFill>
-              </a:defRPr>
-            </a:pPr>
-            <a:r>
-              <a:t>0.903</a:t>
+              <a:defRPr sz="1300" b="1">
+                <a:solidFill>
+                  <a:srgbClr val="FF5C5C"/>
+                </a:solidFill>
+              </a:defRPr>
+            </a:pPr>
+            <a:r>
+              <a:t>0.903 (91%)</a:t>
             </a:r>
           </a:p>
         </p:txBody>
@@ -11016,8 +11016,8 @@
         </p:nvSpPr>
         <p:spPr>
           <a:xfrm>
-            <a:off x="3931920" y="2176272"/>
-            <a:ext cx="1097280" cy="411480"/>
+            <a:off x="3657600" y="2176272"/>
+            <a:ext cx="1188720" cy="411480"/>
           </a:xfrm>
           <a:prstGeom prst="rect">
             <a:avLst/>
@@ -11029,14 +11029,14 @@
           <a:lstStyle/>
           <a:p>
             <a:pPr algn="ctr">
-              <a:defRPr sz="1400" b="0">
-                <a:solidFill>
-                  <a:srgbClr val="A0A0A0"/>
-                </a:solidFill>
-              </a:defRPr>
-            </a:pPr>
-            <a:r>
-              <a:t>91.4%</a:t>
+              <a:defRPr sz="1300" b="1">
+                <a:solidFill>
+                  <a:srgbClr val="00C9A7"/>
+                </a:solidFill>
+              </a:defRPr>
+            </a:pPr>
+            <a:r>
+              <a:t>0.962 (97%)</a:t>
             </a:r>
           </a:p>
         </p:txBody>
@@ -11049,8 +11049,8 @@
         </p:nvSpPr>
         <p:spPr>
           <a:xfrm>
-            <a:off x="5212080" y="2176272"/>
-            <a:ext cx="1097280" cy="411480"/>
+            <a:off x="5029200" y="2176272"/>
+            <a:ext cx="1188720" cy="411480"/>
           </a:xfrm>
           <a:prstGeom prst="rect">
             <a:avLst/>
@@ -11062,14 +11062,14 @@
           <a:lstStyle/>
           <a:p>
             <a:pPr algn="ctr">
-              <a:defRPr sz="1400" b="1">
-                <a:solidFill>
-                  <a:srgbClr val="2D2D3F"/>
-                </a:solidFill>
-              </a:defRPr>
-            </a:pPr>
-            <a:r>
-              <a:t>0.919</a:t>
+              <a:defRPr sz="1300" b="1">
+                <a:solidFill>
+                  <a:srgbClr val="A0A0A0"/>
+                </a:solidFill>
+              </a:defRPr>
+            </a:pPr>
+            <a:r>
+              <a:t>0.919 (93%)</a:t>
             </a:r>
           </a:p>
         </p:txBody>
@@ -11083,7 +11083,7 @@
         <p:spPr>
           <a:xfrm>
             <a:off x="6400800" y="2176272"/>
-            <a:ext cx="1097280" cy="411480"/>
+            <a:ext cx="1645920" cy="411480"/>
           </a:xfrm>
           <a:prstGeom prst="rect">
             <a:avLst/>
@@ -11095,14 +11095,14 @@
           <a:lstStyle/>
           <a:p>
             <a:pPr algn="ctr">
-              <a:defRPr sz="1400" b="0">
+              <a:defRPr sz="1200" b="0">
                 <a:solidFill>
                   <a:srgbClr val="A0A0A0"/>
                 </a:solidFill>
               </a:defRPr>
             </a:pPr>
             <a:r>
-              <a:t>93.2%</a:t>
+              <a:t>p=0.82 n.s.</a:t>
             </a:r>
           </a:p>
         </p:txBody>
@@ -11115,7 +11115,7 @@
         </p:nvSpPr>
         <p:spPr>
           <a:xfrm>
-            <a:off x="7589520" y="2176272"/>
+            <a:off x="8138160" y="2176272"/>
             <a:ext cx="1645920" cy="411480"/>
           </a:xfrm>
           <a:prstGeom prst="rect">
@@ -11128,14 +11128,14 @@
           <a:lstStyle/>
           <a:p>
             <a:pPr algn="ctr">
-              <a:defRPr sz="1300" b="0">
+              <a:defRPr sz="1200" b="0">
                 <a:solidFill>
                   <a:srgbClr val="A0A0A0"/>
                 </a:solidFill>
               </a:defRPr>
             </a:pPr>
             <a:r>
-              <a:t>1.8pp gap</a:t>
+              <a:t>p=0.38 n.s.</a:t>
             </a:r>
           </a:p>
         </p:txBody>
@@ -11148,8 +11148,8 @@
         </p:nvSpPr>
         <p:spPr>
           <a:xfrm>
-            <a:off x="9418320" y="2176272"/>
-            <a:ext cx="2103120" cy="411480"/>
+            <a:off x="9875520" y="2176272"/>
+            <a:ext cx="1920240" cy="411480"/>
           </a:xfrm>
           <a:prstGeom prst="rect">
             <a:avLst/>
@@ -11161,14 +11161,14 @@
           <a:lstStyle/>
           <a:p>
             <a:pPr algn="ctr">
-              <a:defRPr sz="1200" b="0">
+              <a:defRPr sz="1200" b="1">
                 <a:solidFill>
                   <a:srgbClr val="00C9A7"/>
                 </a:solidFill>
               </a:defRPr>
             </a:pPr>
             <a:r>
-              <a:t>p=0.82  Not significant</a:t>
+              <a:t>At human level</a:t>
             </a:r>
           </a:p>
         </p:txBody>
@@ -11181,8 +11181,8 @@
         </p:nvSpPr>
         <p:spPr>
           <a:xfrm>
-            <a:off x="457200" y="2743200"/>
-            <a:ext cx="11247120" cy="548640"/>
+            <a:off x="274320" y="2743200"/>
+            <a:ext cx="11612880" cy="548640"/>
           </a:xfrm>
           <a:prstGeom prst="roundRect">
             <a:avLst/>
@@ -11225,8 +11225,8 @@
         </p:nvSpPr>
         <p:spPr>
           <a:xfrm>
-            <a:off x="640080" y="2816352"/>
-            <a:ext cx="2011680" cy="411480"/>
+            <a:off x="457200" y="2816352"/>
+            <a:ext cx="1828800" cy="411480"/>
           </a:xfrm>
           <a:prstGeom prst="rect">
             <a:avLst/>
@@ -11238,7 +11238,7 @@
           <a:lstStyle/>
           <a:p>
             <a:pPr algn="l">
-              <a:defRPr sz="1500" b="1">
+              <a:defRPr sz="1400" b="1">
                 <a:solidFill>
                   <a:srgbClr val="FF8C42"/>
                 </a:solidFill>
@@ -11258,8 +11258,8 @@
         </p:nvSpPr>
         <p:spPr>
           <a:xfrm>
-            <a:off x="2743200" y="2816352"/>
-            <a:ext cx="1097280" cy="411480"/>
+            <a:off x="2377440" y="2816352"/>
+            <a:ext cx="1188720" cy="411480"/>
           </a:xfrm>
           <a:prstGeom prst="rect">
             <a:avLst/>
@@ -11271,14 +11271,14 @@
           <a:lstStyle/>
           <a:p>
             <a:pPr algn="ctr">
-              <a:defRPr sz="1400" b="1">
-                <a:solidFill>
-                  <a:srgbClr val="2D2D3F"/>
-                </a:solidFill>
-              </a:defRPr>
-            </a:pPr>
-            <a:r>
-              <a:t>0.835</a:t>
+              <a:defRPr sz="1300" b="1">
+                <a:solidFill>
+                  <a:srgbClr val="FF5C5C"/>
+                </a:solidFill>
+              </a:defRPr>
+            </a:pPr>
+            <a:r>
+              <a:t>0.835 (85%)</a:t>
             </a:r>
           </a:p>
         </p:txBody>
@@ -11291,8 +11291,8 @@
         </p:nvSpPr>
         <p:spPr>
           <a:xfrm>
-            <a:off x="3931920" y="2816352"/>
-            <a:ext cx="1097280" cy="411480"/>
+            <a:off x="3657600" y="2816352"/>
+            <a:ext cx="1188720" cy="411480"/>
           </a:xfrm>
           <a:prstGeom prst="rect">
             <a:avLst/>
@@ -11304,14 +11304,14 @@
           <a:lstStyle/>
           <a:p>
             <a:pPr algn="ctr">
-              <a:defRPr sz="1400" b="0">
-                <a:solidFill>
-                  <a:srgbClr val="A0A0A0"/>
-                </a:solidFill>
-              </a:defRPr>
-            </a:pPr>
-            <a:r>
-              <a:t>85.4%</a:t>
+              <a:defRPr sz="1300" b="1">
+                <a:solidFill>
+                  <a:srgbClr val="FF5C5C"/>
+                </a:solidFill>
+              </a:defRPr>
+            </a:pPr>
+            <a:r>
+              <a:t>0.854 (88%)</a:t>
             </a:r>
           </a:p>
         </p:txBody>
@@ -11324,8 +11324,8 @@
         </p:nvSpPr>
         <p:spPr>
           <a:xfrm>
-            <a:off x="5212080" y="2816352"/>
-            <a:ext cx="1097280" cy="411480"/>
+            <a:off x="5029200" y="2816352"/>
+            <a:ext cx="1188720" cy="411480"/>
           </a:xfrm>
           <a:prstGeom prst="rect">
             <a:avLst/>
@@ -11337,14 +11337,14 @@
           <a:lstStyle/>
           <a:p>
             <a:pPr algn="ctr">
-              <a:defRPr sz="1400" b="1">
-                <a:solidFill>
-                  <a:srgbClr val="2D2D3F"/>
-                </a:solidFill>
-              </a:defRPr>
-            </a:pPr>
-            <a:r>
-              <a:t>0.878</a:t>
+              <a:defRPr sz="1300" b="1">
+                <a:solidFill>
+                  <a:srgbClr val="A0A0A0"/>
+                </a:solidFill>
+              </a:defRPr>
+            </a:pPr>
+            <a:r>
+              <a:t>0.878 (89%)</a:t>
             </a:r>
           </a:p>
         </p:txBody>
@@ -11358,7 +11358,7 @@
         <p:spPr>
           <a:xfrm>
             <a:off x="6400800" y="2816352"/>
-            <a:ext cx="1097280" cy="411480"/>
+            <a:ext cx="1645920" cy="411480"/>
           </a:xfrm>
           <a:prstGeom prst="rect">
             <a:avLst/>
@@ -11370,14 +11370,14 @@
           <a:lstStyle/>
           <a:p>
             <a:pPr algn="ctr">
-              <a:defRPr sz="1400" b="0">
+              <a:defRPr sz="1200" b="0">
                 <a:solidFill>
                   <a:srgbClr val="A0A0A0"/>
                 </a:solidFill>
               </a:defRPr>
             </a:pPr>
             <a:r>
-              <a:t>88.9%</a:t>
+              <a:t>p=0.58 n.s.</a:t>
             </a:r>
           </a:p>
         </p:txBody>
@@ -11390,7 +11390,7 @@
         </p:nvSpPr>
         <p:spPr>
           <a:xfrm>
-            <a:off x="7589520" y="2816352"/>
+            <a:off x="8138160" y="2816352"/>
             <a:ext cx="1645920" cy="411480"/>
           </a:xfrm>
           <a:prstGeom prst="rect">
@@ -11403,14 +11403,14 @@
           <a:lstStyle/>
           <a:p>
             <a:pPr algn="ctr">
-              <a:defRPr sz="1300" b="0">
+              <a:defRPr sz="1200" b="0">
                 <a:solidFill>
                   <a:srgbClr val="A0A0A0"/>
                 </a:solidFill>
               </a:defRPr>
             </a:pPr>
             <a:r>
-              <a:t>3.5pp gap</a:t>
+              <a:t>p=0.72 n.s.</a:t>
             </a:r>
           </a:p>
         </p:txBody>
@@ -11423,8 +11423,8 @@
         </p:nvSpPr>
         <p:spPr>
           <a:xfrm>
-            <a:off x="9418320" y="2816352"/>
-            <a:ext cx="2103120" cy="411480"/>
+            <a:off x="9875520" y="2816352"/>
+            <a:ext cx="1920240" cy="411480"/>
           </a:xfrm>
           <a:prstGeom prst="rect">
             <a:avLst/>
@@ -11436,14 +11436,14 @@
           <a:lstStyle/>
           <a:p>
             <a:pPr algn="ctr">
-              <a:defRPr sz="1200" b="0">
+              <a:defRPr sz="1200" b="1">
                 <a:solidFill>
                   <a:srgbClr val="00C9A7"/>
                 </a:solidFill>
               </a:defRPr>
             </a:pPr>
             <a:r>
-              <a:t>p=0.58  Not significant</a:t>
+              <a:t>At human level</a:t>
             </a:r>
           </a:p>
         </p:txBody>
@@ -11456,8 +11456,8 @@
         </p:nvSpPr>
         <p:spPr>
           <a:xfrm>
-            <a:off x="457200" y="3383279"/>
-            <a:ext cx="11247120" cy="548640"/>
+            <a:off x="274320" y="3383279"/>
+            <a:ext cx="11612880" cy="548640"/>
           </a:xfrm>
           <a:prstGeom prst="roundRect">
             <a:avLst/>
@@ -11500,8 +11500,8 @@
         </p:nvSpPr>
         <p:spPr>
           <a:xfrm>
-            <a:off x="640080" y="3456431"/>
-            <a:ext cx="2011680" cy="411480"/>
+            <a:off x="457200" y="3456431"/>
+            <a:ext cx="1828800" cy="411480"/>
           </a:xfrm>
           <a:prstGeom prst="rect">
             <a:avLst/>
@@ -11513,7 +11513,7 @@
           <a:lstStyle/>
           <a:p>
             <a:pPr algn="l">
-              <a:defRPr sz="1500" b="1">
+              <a:defRPr sz="1400" b="1">
                 <a:solidFill>
                   <a:srgbClr val="FF5C5C"/>
                 </a:solidFill>
@@ -11533,8 +11533,8 @@
         </p:nvSpPr>
         <p:spPr>
           <a:xfrm>
-            <a:off x="2743200" y="3456431"/>
-            <a:ext cx="1097280" cy="411480"/>
+            <a:off x="2377440" y="3456431"/>
+            <a:ext cx="1188720" cy="411480"/>
           </a:xfrm>
           <a:prstGeom prst="rect">
             <a:avLst/>
@@ -11546,14 +11546,14 @@
           <a:lstStyle/>
           <a:p>
             <a:pPr algn="ctr">
-              <a:defRPr sz="1400" b="1">
-                <a:solidFill>
-                  <a:srgbClr val="2D2D3F"/>
-                </a:solidFill>
-              </a:defRPr>
-            </a:pPr>
-            <a:r>
-              <a:t>0.558</a:t>
+              <a:defRPr sz="1300" b="1">
+                <a:solidFill>
+                  <a:srgbClr val="FF5C5C"/>
+                </a:solidFill>
+              </a:defRPr>
+            </a:pPr>
+            <a:r>
+              <a:t>0.558 (60%)</a:t>
             </a:r>
           </a:p>
         </p:txBody>
@@ -11566,8 +11566,8 @@
         </p:nvSpPr>
         <p:spPr>
           <a:xfrm>
-            <a:off x="3931920" y="3456431"/>
-            <a:ext cx="1097280" cy="411480"/>
+            <a:off x="3657600" y="3456431"/>
+            <a:ext cx="1188720" cy="411480"/>
           </a:xfrm>
           <a:prstGeom prst="rect">
             <a:avLst/>
@@ -11579,14 +11579,14 @@
           <a:lstStyle/>
           <a:p>
             <a:pPr algn="ctr">
-              <a:defRPr sz="1400" b="0">
-                <a:solidFill>
-                  <a:srgbClr val="A0A0A0"/>
-                </a:solidFill>
-              </a:defRPr>
-            </a:pPr>
-            <a:r>
-              <a:t>60.5%</a:t>
+              <a:defRPr sz="1300" b="1">
+                <a:solidFill>
+                  <a:srgbClr val="FF5C5C"/>
+                </a:solidFill>
+              </a:defRPr>
+            </a:pPr>
+            <a:r>
+              <a:t>0.557 (60%)</a:t>
             </a:r>
           </a:p>
         </p:txBody>
@@ -11599,8 +11599,8 @@
         </p:nvSpPr>
         <p:spPr>
           <a:xfrm>
-            <a:off x="5212080" y="3456431"/>
-            <a:ext cx="1097280" cy="411480"/>
+            <a:off x="5029200" y="3456431"/>
+            <a:ext cx="1188720" cy="411480"/>
           </a:xfrm>
           <a:prstGeom prst="rect">
             <a:avLst/>
@@ -11612,14 +11612,14 @@
           <a:lstStyle/>
           <a:p>
             <a:pPr algn="ctr">
-              <a:defRPr sz="1400" b="1">
-                <a:solidFill>
-                  <a:srgbClr val="2D2D3F"/>
-                </a:solidFill>
-              </a:defRPr>
-            </a:pPr>
-            <a:r>
-              <a:t>0.583</a:t>
+              <a:defRPr sz="1300" b="1">
+                <a:solidFill>
+                  <a:srgbClr val="A0A0A0"/>
+                </a:solidFill>
+              </a:defRPr>
+            </a:pPr>
+            <a:r>
+              <a:t>0.583 (64%)</a:t>
             </a:r>
           </a:p>
         </p:txBody>
@@ -11633,7 +11633,7 @@
         <p:spPr>
           <a:xfrm>
             <a:off x="6400800" y="3456431"/>
-            <a:ext cx="1097280" cy="411480"/>
+            <a:ext cx="1645920" cy="411480"/>
           </a:xfrm>
           <a:prstGeom prst="rect">
             <a:avLst/>
@@ -11645,14 +11645,14 @@
           <a:lstStyle/>
           <a:p>
             <a:pPr algn="ctr">
-              <a:defRPr sz="1400" b="0">
+              <a:defRPr sz="1200" b="0">
                 <a:solidFill>
                   <a:srgbClr val="A0A0A0"/>
                 </a:solidFill>
               </a:defRPr>
             </a:pPr>
             <a:r>
-              <a:t>64.3%</a:t>
+              <a:t>p=0.77 n.s.</a:t>
             </a:r>
           </a:p>
         </p:txBody>
@@ -11665,7 +11665,7 @@
         </p:nvSpPr>
         <p:spPr>
           <a:xfrm>
-            <a:off x="7589520" y="3456431"/>
+            <a:off x="8138160" y="3456431"/>
             <a:ext cx="1645920" cy="411480"/>
           </a:xfrm>
           <a:prstGeom prst="rect">
@@ -11678,14 +11678,14 @@
           <a:lstStyle/>
           <a:p>
             <a:pPr algn="ctr">
-              <a:defRPr sz="1300" b="0">
+              <a:defRPr sz="1200" b="0">
                 <a:solidFill>
                   <a:srgbClr val="A0A0A0"/>
                 </a:solidFill>
               </a:defRPr>
             </a:pPr>
             <a:r>
-              <a:t>3.8pp gap</a:t>
+              <a:t>p=0.76 n.s.</a:t>
             </a:r>
           </a:p>
         </p:txBody>
@@ -11698,8 +11698,8 @@
         </p:nvSpPr>
         <p:spPr>
           <a:xfrm>
-            <a:off x="9418320" y="3456431"/>
-            <a:ext cx="2103120" cy="411480"/>
+            <a:off x="9875520" y="3456431"/>
+            <a:ext cx="1920240" cy="411480"/>
           </a:xfrm>
           <a:prstGeom prst="rect">
             <a:avLst/>
@@ -11711,14 +11711,14 @@
           <a:lstStyle/>
           <a:p>
             <a:pPr algn="ctr">
-              <a:defRPr sz="1200" b="0">
+              <a:defRPr sz="1200" b="1">
                 <a:solidFill>
                   <a:srgbClr val="00C9A7"/>
                 </a:solidFill>
               </a:defRPr>
             </a:pPr>
             <a:r>
-              <a:t>p=0.77  Not significant</a:t>
+              <a:t>At human level</a:t>
             </a:r>
           </a:p>
         </p:txBody>
@@ -11731,8 +11731,8 @@
         </p:nvSpPr>
         <p:spPr>
           <a:xfrm>
-            <a:off x="457200" y="4023359"/>
-            <a:ext cx="11247120" cy="548640"/>
+            <a:off x="274320" y="4023359"/>
+            <a:ext cx="11612880" cy="548640"/>
           </a:xfrm>
           <a:prstGeom prst="roundRect">
             <a:avLst/>
@@ -11775,8 +11775,8 @@
         </p:nvSpPr>
         <p:spPr>
           <a:xfrm>
-            <a:off x="640080" y="4096511"/>
-            <a:ext cx="2011680" cy="411480"/>
+            <a:off x="457200" y="4096511"/>
+            <a:ext cx="1828800" cy="411480"/>
           </a:xfrm>
           <a:prstGeom prst="rect">
             <a:avLst/>
@@ -11788,7 +11788,7 @@
           <a:lstStyle/>
           <a:p>
             <a:pPr algn="l">
-              <a:defRPr sz="1500" b="1">
+              <a:defRPr sz="1400" b="1">
                 <a:solidFill>
                   <a:srgbClr val="A85CFF"/>
                 </a:solidFill>
@@ -11808,8 +11808,8 @@
         </p:nvSpPr>
         <p:spPr>
           <a:xfrm>
-            <a:off x="2743200" y="4096511"/>
-            <a:ext cx="1097280" cy="411480"/>
+            <a:off x="2377440" y="4096511"/>
+            <a:ext cx="1188720" cy="411480"/>
           </a:xfrm>
           <a:prstGeom prst="rect">
             <a:avLst/>
@@ -11821,14 +11821,14 @@
           <a:lstStyle/>
           <a:p>
             <a:pPr algn="ctr">
-              <a:defRPr sz="1400" b="1">
-                <a:solidFill>
-                  <a:srgbClr val="2D2D3F"/>
-                </a:solidFill>
-              </a:defRPr>
-            </a:pPr>
-            <a:r>
-              <a:t>0.922</a:t>
+              <a:defRPr sz="1300" b="1">
+                <a:solidFill>
+                  <a:srgbClr val="00C9A7"/>
+                </a:solidFill>
+              </a:defRPr>
+            </a:pPr>
+            <a:r>
+              <a:t>0.922 (92%)</a:t>
             </a:r>
           </a:p>
         </p:txBody>
@@ -11841,8 +11841,8 @@
         </p:nvSpPr>
         <p:spPr>
           <a:xfrm>
-            <a:off x="3931920" y="4096511"/>
-            <a:ext cx="1097280" cy="411480"/>
+            <a:off x="3657600" y="4096511"/>
+            <a:ext cx="1188720" cy="411480"/>
           </a:xfrm>
           <a:prstGeom prst="rect">
             <a:avLst/>
@@ -11854,14 +11854,14 @@
           <a:lstStyle/>
           <a:p>
             <a:pPr algn="ctr">
-              <a:defRPr sz="1400" b="0">
-                <a:solidFill>
-                  <a:srgbClr val="A0A0A0"/>
-                </a:solidFill>
-              </a:defRPr>
-            </a:pPr>
-            <a:r>
-              <a:t>92.4%</a:t>
+              <a:defRPr sz="1300" b="1">
+                <a:solidFill>
+                  <a:srgbClr val="00C9A7"/>
+                </a:solidFill>
+              </a:defRPr>
+            </a:pPr>
+            <a:r>
+              <a:t>0.904 (91%)</a:t>
             </a:r>
           </a:p>
         </p:txBody>
@@ -11874,8 +11874,8 @@
         </p:nvSpPr>
         <p:spPr>
           <a:xfrm>
-            <a:off x="5212080" y="4096511"/>
-            <a:ext cx="1097280" cy="411480"/>
+            <a:off x="5029200" y="4096511"/>
+            <a:ext cx="1188720" cy="411480"/>
           </a:xfrm>
           <a:prstGeom prst="rect">
             <a:avLst/>
@@ -11887,14 +11887,14 @@
           <a:lstStyle/>
           <a:p>
             <a:pPr algn="ctr">
-              <a:defRPr sz="1400" b="1">
-                <a:solidFill>
-                  <a:srgbClr val="2D2D3F"/>
-                </a:solidFill>
-              </a:defRPr>
-            </a:pPr>
-            <a:r>
-              <a:t>0.881</a:t>
+              <a:defRPr sz="1300" b="1">
+                <a:solidFill>
+                  <a:srgbClr val="A0A0A0"/>
+                </a:solidFill>
+              </a:defRPr>
+            </a:pPr>
+            <a:r>
+              <a:t>0.881 (89%)</a:t>
             </a:r>
           </a:p>
         </p:txBody>
@@ -11908,7 +11908,7 @@
         <p:spPr>
           <a:xfrm>
             <a:off x="6400800" y="4096511"/>
-            <a:ext cx="1097280" cy="411480"/>
+            <a:ext cx="1645920" cy="411480"/>
           </a:xfrm>
           <a:prstGeom prst="rect">
             <a:avLst/>
@@ -11920,14 +11920,14 @@
           <a:lstStyle/>
           <a:p>
             <a:pPr algn="ctr">
-              <a:defRPr sz="1400" b="0">
+              <a:defRPr sz="1200" b="0">
                 <a:solidFill>
                   <a:srgbClr val="A0A0A0"/>
                 </a:solidFill>
               </a:defRPr>
             </a:pPr>
             <a:r>
-              <a:t>88.6%</a:t>
+              <a:t>p=0.26 n.s.</a:t>
             </a:r>
           </a:p>
         </p:txBody>
@@ -11940,7 +11940,7 @@
         </p:nvSpPr>
         <p:spPr>
           <a:xfrm>
-            <a:off x="7589520" y="4096511"/>
+            <a:off x="8138160" y="4096511"/>
             <a:ext cx="1645920" cy="411480"/>
           </a:xfrm>
           <a:prstGeom prst="rect">
@@ -11953,14 +11953,14 @@
           <a:lstStyle/>
           <a:p>
             <a:pPr algn="ctr">
-              <a:defRPr sz="1300" b="1">
-                <a:solidFill>
-                  <a:srgbClr val="00C9A7"/>
-                </a:solidFill>
-              </a:defRPr>
-            </a:pPr>
-            <a:r>
-              <a:t>Above human</a:t>
+              <a:defRPr sz="1200" b="0">
+                <a:solidFill>
+                  <a:srgbClr val="A0A0A0"/>
+                </a:solidFill>
+              </a:defRPr>
+            </a:pPr>
+            <a:r>
+              <a:t>p=0.55 n.s.</a:t>
             </a:r>
           </a:p>
         </p:txBody>
@@ -11973,8 +11973,8 @@
         </p:nvSpPr>
         <p:spPr>
           <a:xfrm>
-            <a:off x="9418320" y="4096511"/>
-            <a:ext cx="2103120" cy="411480"/>
+            <a:off x="9875520" y="4096511"/>
+            <a:ext cx="1920240" cy="411480"/>
           </a:xfrm>
           <a:prstGeom prst="rect">
             <a:avLst/>
@@ -11986,14 +11986,14 @@
           <a:lstStyle/>
           <a:p>
             <a:pPr algn="ctr">
-              <a:defRPr sz="1200" b="0">
+              <a:defRPr sz="1200" b="1">
                 <a:solidFill>
                   <a:srgbClr val="00C9A7"/>
                 </a:solidFill>
               </a:defRPr>
             </a:pPr>
             <a:r>
-              <a:t>p=0.26  Not significant</a:t>
+              <a:t>At human level</a:t>
             </a:r>
           </a:p>
         </p:txBody>
@@ -12006,8 +12006,8 @@
         </p:nvSpPr>
         <p:spPr>
           <a:xfrm>
-            <a:off x="457200" y="4663440"/>
-            <a:ext cx="11247120" cy="548640"/>
+            <a:off x="274320" y="4663440"/>
+            <a:ext cx="11612880" cy="548640"/>
           </a:xfrm>
           <a:prstGeom prst="roundRect">
             <a:avLst/>
@@ -12050,8 +12050,8 @@
         </p:nvSpPr>
         <p:spPr>
           <a:xfrm>
-            <a:off x="640080" y="4736592"/>
-            <a:ext cx="2011680" cy="411480"/>
+            <a:off x="457200" y="4736592"/>
+            <a:ext cx="1828800" cy="411480"/>
           </a:xfrm>
           <a:prstGeom prst="rect">
             <a:avLst/>
@@ -12063,7 +12063,7 @@
           <a:lstStyle/>
           <a:p>
             <a:pPr algn="l">
-              <a:defRPr sz="1500" b="1">
+              <a:defRPr sz="1400" b="1">
                 <a:solidFill>
                   <a:srgbClr val="00C9A7"/>
                 </a:solidFill>
@@ -12083,8 +12083,8 @@
         </p:nvSpPr>
         <p:spPr>
           <a:xfrm>
-            <a:off x="2743200" y="4736592"/>
-            <a:ext cx="1097280" cy="411480"/>
+            <a:off x="2377440" y="4736592"/>
+            <a:ext cx="1188720" cy="411480"/>
           </a:xfrm>
           <a:prstGeom prst="rect">
             <a:avLst/>
@@ -12096,14 +12096,14 @@
           <a:lstStyle/>
           <a:p>
             <a:pPr algn="ctr">
-              <a:defRPr sz="1400" b="1">
-                <a:solidFill>
-                  <a:srgbClr val="2D2D3F"/>
-                </a:solidFill>
-              </a:defRPr>
-            </a:pPr>
-            <a:r>
-              <a:t>0.826</a:t>
+              <a:defRPr sz="1300" b="1">
+                <a:solidFill>
+                  <a:srgbClr val="00C9A7"/>
+                </a:solidFill>
+              </a:defRPr>
+            </a:pPr>
+            <a:r>
+              <a:t>0.826 (88%)</a:t>
             </a:r>
           </a:p>
         </p:txBody>
@@ -12116,8 +12116,8 @@
         </p:nvSpPr>
         <p:spPr>
           <a:xfrm>
-            <a:off x="3931920" y="4736592"/>
-            <a:ext cx="1097280" cy="411480"/>
+            <a:off x="3657600" y="4736592"/>
+            <a:ext cx="1188720" cy="411480"/>
           </a:xfrm>
           <a:prstGeom prst="rect">
             <a:avLst/>
@@ -12129,14 +12129,14 @@
           <a:lstStyle/>
           <a:p>
             <a:pPr algn="ctr">
-              <a:defRPr sz="1400" b="0">
-                <a:solidFill>
-                  <a:srgbClr val="A0A0A0"/>
-                </a:solidFill>
-              </a:defRPr>
-            </a:pPr>
-            <a:r>
-              <a:t>88.3%</a:t>
+              <a:defRPr sz="1300" b="1">
+                <a:solidFill>
+                  <a:srgbClr val="FF5C5C"/>
+                </a:solidFill>
+              </a:defRPr>
+            </a:pPr>
+            <a:r>
+              <a:t>0.756 (84%)</a:t>
             </a:r>
           </a:p>
         </p:txBody>
@@ -12149,8 +12149,8 @@
         </p:nvSpPr>
         <p:spPr>
           <a:xfrm>
-            <a:off x="5212080" y="4736592"/>
-            <a:ext cx="1097280" cy="411480"/>
+            <a:off x="5029200" y="4736592"/>
+            <a:ext cx="1188720" cy="411480"/>
           </a:xfrm>
           <a:prstGeom prst="rect">
             <a:avLst/>
@@ -12162,14 +12162,14 @@
           <a:lstStyle/>
           <a:p>
             <a:pPr algn="ctr">
-              <a:defRPr sz="1400" b="1">
-                <a:solidFill>
-                  <a:srgbClr val="2D2D3F"/>
-                </a:solidFill>
-              </a:defRPr>
-            </a:pPr>
-            <a:r>
-              <a:t>0.792</a:t>
+              <a:defRPr sz="1300" b="1">
+                <a:solidFill>
+                  <a:srgbClr val="A0A0A0"/>
+                </a:solidFill>
+              </a:defRPr>
+            </a:pPr>
+            <a:r>
+              <a:t>0.792 (86%)</a:t>
             </a:r>
           </a:p>
         </p:txBody>
@@ -12183,7 +12183,7 @@
         <p:spPr>
           <a:xfrm>
             <a:off x="6400800" y="4736592"/>
-            <a:ext cx="1097280" cy="411480"/>
+            <a:ext cx="1645920" cy="411480"/>
           </a:xfrm>
           <a:prstGeom prst="rect">
             <a:avLst/>
@@ -12195,14 +12195,14 @@
           <a:lstStyle/>
           <a:p>
             <a:pPr algn="ctr">
-              <a:defRPr sz="1400" b="0">
+              <a:defRPr sz="1200" b="0">
                 <a:solidFill>
                   <a:srgbClr val="A0A0A0"/>
                 </a:solidFill>
               </a:defRPr>
             </a:pPr>
             <a:r>
-              <a:t>86.0%</a:t>
+              <a:t>p=0.76 n.s.</a:t>
             </a:r>
           </a:p>
         </p:txBody>
@@ -12215,7 +12215,7 @@
         </p:nvSpPr>
         <p:spPr>
           <a:xfrm>
-            <a:off x="7589520" y="4736592"/>
+            <a:off x="8138160" y="4736592"/>
             <a:ext cx="1645920" cy="411480"/>
           </a:xfrm>
           <a:prstGeom prst="rect">
@@ -12228,14 +12228,14 @@
           <a:lstStyle/>
           <a:p>
             <a:pPr algn="ctr">
-              <a:defRPr sz="1300" b="1">
-                <a:solidFill>
-                  <a:srgbClr val="00C9A7"/>
-                </a:solidFill>
-              </a:defRPr>
-            </a:pPr>
-            <a:r>
-              <a:t>Above human</a:t>
+              <a:defRPr sz="1200" b="0">
+                <a:solidFill>
+                  <a:srgbClr val="A0A0A0"/>
+                </a:solidFill>
+              </a:defRPr>
+            </a:pPr>
+            <a:r>
+              <a:t>p=0.70 n.s.</a:t>
             </a:r>
           </a:p>
         </p:txBody>
@@ -12248,8 +12248,8 @@
         </p:nvSpPr>
         <p:spPr>
           <a:xfrm>
-            <a:off x="9418320" y="4736592"/>
-            <a:ext cx="2103120" cy="411480"/>
+            <a:off x="9875520" y="4736592"/>
+            <a:ext cx="1920240" cy="411480"/>
           </a:xfrm>
           <a:prstGeom prst="rect">
             <a:avLst/>
@@ -12261,14 +12261,14 @@
           <a:lstStyle/>
           <a:p>
             <a:pPr algn="ctr">
-              <a:defRPr sz="1200" b="0">
+              <a:defRPr sz="1200" b="1">
                 <a:solidFill>
                   <a:srgbClr val="00C9A7"/>
                 </a:solidFill>
               </a:defRPr>
             </a:pPr>
             <a:r>
-              <a:t>p=0.76  Not significant</a:t>
+              <a:t>At human level</a:t>
             </a:r>
           </a:p>
         </p:txBody>
@@ -12281,8 +12281,8 @@
         </p:nvSpPr>
         <p:spPr>
           <a:xfrm>
-            <a:off x="457200" y="5303520"/>
-            <a:ext cx="11247120" cy="548640"/>
+            <a:off x="274320" y="5303520"/>
+            <a:ext cx="11612880" cy="548640"/>
           </a:xfrm>
           <a:prstGeom prst="roundRect">
             <a:avLst/>
@@ -12325,8 +12325,8 @@
         </p:nvSpPr>
         <p:spPr>
           <a:xfrm>
-            <a:off x="640080" y="5376672"/>
-            <a:ext cx="2011680" cy="411480"/>
+            <a:off x="457200" y="5376672"/>
+            <a:ext cx="1828800" cy="411480"/>
           </a:xfrm>
           <a:prstGeom prst="rect">
             <a:avLst/>
@@ -12338,7 +12338,7 @@
           <a:lstStyle/>
           <a:p>
             <a:pPr algn="l">
-              <a:defRPr sz="1500" b="1">
+              <a:defRPr sz="1400" b="1">
                 <a:solidFill>
                   <a:srgbClr val="0096D6"/>
                 </a:solidFill>
@@ -12358,8 +12358,8 @@
         </p:nvSpPr>
         <p:spPr>
           <a:xfrm>
-            <a:off x="2743200" y="5376672"/>
-            <a:ext cx="1097280" cy="411480"/>
+            <a:off x="2377440" y="5376672"/>
+            <a:ext cx="1188720" cy="411480"/>
           </a:xfrm>
           <a:prstGeom prst="rect">
             <a:avLst/>
@@ -12371,14 +12371,14 @@
           <a:lstStyle/>
           <a:p>
             <a:pPr algn="ctr">
-              <a:defRPr sz="1400" b="1">
-                <a:solidFill>
-                  <a:srgbClr val="2D2D3F"/>
-                </a:solidFill>
-              </a:defRPr>
-            </a:pPr>
-            <a:r>
-              <a:t>0.566</a:t>
+              <a:defRPr sz="1300" b="1">
+                <a:solidFill>
+                  <a:srgbClr val="00C9A7"/>
+                </a:solidFill>
+              </a:defRPr>
+            </a:pPr>
+            <a:r>
+              <a:t>0.566 (58%)</a:t>
             </a:r>
           </a:p>
         </p:txBody>
@@ -12391,8 +12391,8 @@
         </p:nvSpPr>
         <p:spPr>
           <a:xfrm>
-            <a:off x="3931920" y="5376672"/>
-            <a:ext cx="1097280" cy="411480"/>
+            <a:off x="3657600" y="5376672"/>
+            <a:ext cx="1188720" cy="411480"/>
           </a:xfrm>
           <a:prstGeom prst="rect">
             <a:avLst/>
@@ -12404,14 +12404,14 @@
           <a:lstStyle/>
           <a:p>
             <a:pPr algn="ctr">
-              <a:defRPr sz="1400" b="0">
-                <a:solidFill>
-                  <a:srgbClr val="A0A0A0"/>
-                </a:solidFill>
-              </a:defRPr>
-            </a:pPr>
-            <a:r>
-              <a:t>58.3%</a:t>
+              <a:defRPr sz="1300" b="1">
+                <a:solidFill>
+                  <a:srgbClr val="00C9A7"/>
+                </a:solidFill>
+              </a:defRPr>
+            </a:pPr>
+            <a:r>
+              <a:t>0.549 (56%)</a:t>
             </a:r>
           </a:p>
         </p:txBody>
@@ -12424,8 +12424,8 @@
         </p:nvSpPr>
         <p:spPr>
           <a:xfrm>
-            <a:off x="5212080" y="5376672"/>
-            <a:ext cx="1097280" cy="411480"/>
+            <a:off x="5029200" y="5376672"/>
+            <a:ext cx="1188720" cy="411480"/>
           </a:xfrm>
           <a:prstGeom prst="rect">
             <a:avLst/>
@@ -12437,14 +12437,14 @@
           <a:lstStyle/>
           <a:p>
             <a:pPr algn="ctr">
-              <a:defRPr sz="1400" b="1">
-                <a:solidFill>
-                  <a:srgbClr val="2D2D3F"/>
-                </a:solidFill>
-              </a:defRPr>
-            </a:pPr>
-            <a:r>
-              <a:t>0.518</a:t>
+              <a:defRPr sz="1300" b="1">
+                <a:solidFill>
+                  <a:srgbClr val="A0A0A0"/>
+                </a:solidFill>
+              </a:defRPr>
+            </a:pPr>
+            <a:r>
+              <a:t>0.518 (52%)</a:t>
             </a:r>
           </a:p>
         </p:txBody>
@@ -12458,7 +12458,7 @@
         <p:spPr>
           <a:xfrm>
             <a:off x="6400800" y="5376672"/>
-            <a:ext cx="1097280" cy="411480"/>
+            <a:ext cx="1645920" cy="411480"/>
           </a:xfrm>
           <a:prstGeom prst="rect">
             <a:avLst/>
@@ -12470,14 +12470,14 @@
           <a:lstStyle/>
           <a:p>
             <a:pPr algn="ctr">
-              <a:defRPr sz="1400" b="0">
+              <a:defRPr sz="1200" b="0">
                 <a:solidFill>
                   <a:srgbClr val="A0A0A0"/>
                 </a:solidFill>
               </a:defRPr>
             </a:pPr>
             <a:r>
-              <a:t>52.0%</a:t>
+              <a:t>p=0.41 n.s.</a:t>
             </a:r>
           </a:p>
         </p:txBody>
@@ -12490,7 +12490,7 @@
         </p:nvSpPr>
         <p:spPr>
           <a:xfrm>
-            <a:off x="7589520" y="5376672"/>
+            <a:off x="8138160" y="5376672"/>
             <a:ext cx="1645920" cy="411480"/>
           </a:xfrm>
           <a:prstGeom prst="rect">
@@ -12503,14 +12503,14 @@
           <a:lstStyle/>
           <a:p>
             <a:pPr algn="ctr">
-              <a:defRPr sz="1300" b="1">
-                <a:solidFill>
-                  <a:srgbClr val="00C9A7"/>
-                </a:solidFill>
-              </a:defRPr>
-            </a:pPr>
-            <a:r>
-              <a:t>Above human</a:t>
+              <a:defRPr sz="1200" b="0">
+                <a:solidFill>
+                  <a:srgbClr val="A0A0A0"/>
+                </a:solidFill>
+              </a:defRPr>
+            </a:pPr>
+            <a:r>
+              <a:t>p=0.60 n.s.</a:t>
             </a:r>
           </a:p>
         </p:txBody>
@@ -12523,8 +12523,8 @@
         </p:nvSpPr>
         <p:spPr>
           <a:xfrm>
-            <a:off x="9418320" y="5376672"/>
-            <a:ext cx="2103120" cy="411480"/>
+            <a:off x="9875520" y="5376672"/>
+            <a:ext cx="1920240" cy="411480"/>
           </a:xfrm>
           <a:prstGeom prst="rect">
             <a:avLst/>
@@ -12536,14 +12536,14 @@
           <a:lstStyle/>
           <a:p>
             <a:pPr algn="ctr">
-              <a:defRPr sz="1200" b="0">
+              <a:defRPr sz="1200" b="1">
                 <a:solidFill>
                   <a:srgbClr val="00C9A7"/>
                 </a:solidFill>
               </a:defRPr>
             </a:pPr>
             <a:r>
-              <a:t>p=0.41  Not significant</a:t>
+              <a:t>At human level</a:t>
             </a:r>
           </a:p>
         </p:txBody>
@@ -12556,8 +12556,8 @@
         </p:nvSpPr>
         <p:spPr>
           <a:xfrm>
-            <a:off x="457200" y="6035040"/>
-            <a:ext cx="11247120" cy="640080"/>
+            <a:off x="274320" y="6035040"/>
+            <a:ext cx="11612880" cy="640080"/>
           </a:xfrm>
           <a:prstGeom prst="rect">
             <a:avLst/>
@@ -12576,7 +12576,7 @@
               </a:defRPr>
             </a:pPr>
             <a:r>
-              <a:t>Statistical test: Two-tailed z-test on AC₁ difference (SE derived from 95% CI). α = 0.05.</a:t>
+              <a:t>Two-tailed z-test on AC₁ difference (α = 0.05). n.s. = not significant. Green = agent ≥ human, Red = agent &lt; human.</a:t>
             </a:r>
           </a:p>
           <a:p>
@@ -12591,7 +12591,22 @@
               </a:defRPr>
             </a:pPr>
             <a:r>
-              <a:t>No field shows a statistically significant difference between agent and human agreement — the agent performs at human-level across all 6 fields.</a:t>
+              <a:t>No field shows a statistically significant difference — the agent performs at human-level across all 6 fields.</a:t>
+            </a:r>
+          </a:p>
+          <a:p>
+            <a:pPr>
+              <a:spcBef>
+                <a:spcPts val="400"/>
+              </a:spcBef>
+              <a:defRPr sz="1200" b="0">
+                <a:solidFill>
+                  <a:srgbClr val="A0A0A0"/>
+                </a:solidFill>
+              </a:defRPr>
+            </a:pPr>
+            <a:r>
+              <a:t>If significant AND better: agent outperforms human annotators. If significant AND worse: improvement needed.</a:t>
             </a:r>
           </a:p>
         </p:txBody>

</xml_diff>